<commit_message>
course(design): patch the Software Design deck — funnel + composition synthesis
Targeted patch of the R1 rebuild per author brief: adds the Architecture/Design
recursion FUNNEL (slide 9, replacing strategy/tactics); right-angle connectors +
concrete Architecture language (responsibility/boundaries/interfaces/interaction
rules) on the degrees-of-freedom slide; turns slide 22 into the composition TPS
('can a system of correct components still fail to satisfy its specification?');
converts slide 24 into the 'What must compose?' five-checks synthesis; grounds the
latency example (520 ms) with local/system metric callouts; Requirements->Specification
and strategy->'inherited organization' wording fixes; simplifies the closing; deletes
the strategy/tactics final slide (36 slides). OOXML-validator clean.

Co-Authored-By: Claude Opus 4.8 <noreply@anthropic.com>
</commit_message>
<xml_diff>
--- a/course/lectures/act-1-foundations/07-design/1-7-Design.pptx
+++ b/course/lectures/act-1-foundations/07-design/1-7-Design.pptx
@@ -44,7 +44,6 @@
     <p:sldId id="734" r:id="rId133"/>
     <p:sldId id="735" r:id="rId134"/>
     <p:sldId id="736" r:id="rId135"/>
-    <p:sldId id="737" r:id="rId136"/>
   </p:sldIdLst>
   <p:sldSz cx="9144000" cy="6858000" type="screen4x3"/>
   <p:notesSz cx="6858000" cy="9144000"/>
@@ -1106,6 +1105,12 @@
               <a:t xml:space="preserve">- Recover modularity verbally — decomposability, understandability, change containment, failure containment; do not enumerate the five Meyer criteria.</a:t>
             </a:r>
           </a:p>
+          <a:p>
+            <a:r>
+              <a:rPr dirty="0"/>
+              <a:t xml:space="preserve">- Acknowledge the boundary: if a decomposition creates consequential responsibilities and boundaries, Architecture has recurred at this scope (the slide-9 funnel). Not all decomposition is Design — do not let the example imply that it is.</a:t>
+            </a:r>
+          </a:p>
         </p:txBody>
       </p:sp>
     </p:spTree>
@@ -2490,129 +2495,6 @@
             <a:r>
               <a:rPr dirty="0"/>
               <a:t xml:space="preserve">Engineering proceeds downward through constraints and upward through evidence.</a:t>
-            </a:r>
-          </a:p>
-        </p:txBody>
-      </p:sp>
-    </p:spTree>
-  </p:cSld>
-  <p:clrMapOvr>
-    <a:masterClrMapping/>
-  </p:clrMapOvr>
-</p:notes>
-</file>
-
-<file path=ppt/notesSlides/notesSlide36.xml><?xml version="1.0" encoding="utf-8"?>
-<p:notes xmlns:a="http://schemas.openxmlformats.org/drawingml/2006/main" xmlns:p="http://schemas.openxmlformats.org/presentationml/2006/main">
-  <p:cSld>
-    <p:spTree>
-      <p:nvGrpSpPr>
-        <p:cNvPr id="1" name=""/>
-        <p:cNvGrpSpPr/>
-        <p:nvPr/>
-      </p:nvGrpSpPr>
-      <p:grpSpPr>
-        <a:xfrm>
-          <a:off x="0" y="0"/>
-          <a:ext cx="0" cy="0"/>
-          <a:chOff x="0" y="0"/>
-          <a:chExt cx="0" cy="0"/>
-        </a:xfrm>
-      </p:grpSpPr>
-      <p:sp>
-        <p:nvSpPr>
-          <p:cNvPr id="2" name="Notes Placeholder 1"/>
-          <p:cNvSpPr>
-            <a:spLocks noGrp="1"/>
-          </p:cNvSpPr>
-          <p:nvPr>
-            <p:ph type="body" idx="1"/>
-          </p:nvPr>
-        </p:nvSpPr>
-        <p:spPr/>
-        <p:txBody>
-          <a:bodyPr/>
-          <a:lstStyle/>
-          <a:p>
-            <a:r>
-              <a:rPr dirty="0"/>
-              <a:t xml:space="preserve">45 seconds — </a:t>
-            </a:r>
-            <a:r>
-              <a:rPr i="1" dirty="0"/>
-              <a:t>Land the closing sentence and stop.</a:t>
-            </a:r>
-          </a:p>
-          <a:p>
-            <a:endParaRPr dirty="0"/>
-          </a:p>
-          <a:p>
-            <a:r>
-              <a:rPr dirty="0"/>
-              <a:t xml:space="preserve">- Land the two sentences and stop; no third slogan.</a:t>
-            </a:r>
-          </a:p>
-          <a:p>
-            <a:endParaRPr dirty="0"/>
-          </a:p>
-          <a:p>
-            <a:r>
-              <a:rPr dirty="0"/>
-              <a:t xml:space="preserve">=====</a:t>
-            </a:r>
-          </a:p>
-          <a:p>
-            <a:endParaRPr dirty="0"/>
-          </a:p>
-          <a:p>
-            <a:r>
-              <a:rPr dirty="0"/>
-              <a:t xml:space="preserve">Architecture is strategy. Design is tactics.</a:t>
-            </a:r>
-          </a:p>
-          <a:p>
-            <a:endParaRPr dirty="0"/>
-          </a:p>
-          <a:p>
-            <a:r>
-              <a:rPr dirty="0"/>
-              <a:t xml:space="preserve">But that relationship is not one-way. Architecture creates the space within which Design works. Design supplies evidence about whether that space actually permits a satisfactory solution.</a:t>
-            </a:r>
-          </a:p>
-          <a:p>
-            <a:endParaRPr dirty="0"/>
-          </a:p>
-          <a:p>
-            <a:r>
-              <a:rPr dirty="0"/>
-              <a:t xml:space="preserve">That is why good Design is neither unconstrained creativity nor mechanical implementation of somebody else's boxes.</a:t>
-            </a:r>
-          </a:p>
-          <a:p>
-            <a:endParaRPr dirty="0"/>
-          </a:p>
-          <a:p>
-            <a:r>
-              <a:rPr dirty="0"/>
-              <a:t xml:space="preserve">It is engineering within inherited constraints, with enough judgment to recognize when those constraints themselves need to change.</a:t>
-            </a:r>
-          </a:p>
-          <a:p>
-            <a:endParaRPr dirty="0"/>
-          </a:p>
-          <a:p>
-            <a:r>
-              <a:rPr dirty="0"/>
-              <a:t xml:space="preserve">Architecture constrains the available tactics. Design tests whether the strategy is workable.</a:t>
-            </a:r>
-          </a:p>
-          <a:p>
-            <a:endParaRPr dirty="0"/>
-          </a:p>
-          <a:p>
-            <a:r>
-              <a:rPr dirty="0"/>
-              <a:t xml:space="preserve">And stop.</a:t>
             </a:r>
           </a:p>
         </p:txBody>
@@ -8168,7 +8050,7 @@
                   <a:srgbClr val="555960"/>
                 </a:solidFill>
               </a:rPr>
-              <a:t>Replication does not determine consistency. Requirements do.</a:t>
+              <a:t>Replication does not determine consistency. The Specification does.</a:t>
             </a:r>
           </a:p>
         </p:txBody>
@@ -12945,8 +12827,8 @@
           </p:nvCxnSpPr>
           <p:spPr>
             <a:xfrm flipV="1">
-              <a:off x="7550000" y="3100000"/>
-              <a:ext cx="0" cy="700000"/>
+              <a:off x="7550000" y="2930000"/>
+              <a:ext cx="0" cy="870000"/>
             </a:xfrm>
             <a:prstGeom prst="straightConnector1">
               <a:avLst/>
@@ -13070,7 +12952,7 @@
                   <a:srgbClr val="FFFFFF"/>
                 </a:solidFill>
               </a:rPr>
-              <a:t>A mechanism that cannot fit is information about the strategy — escalate it.</a:t>
+              <a:t>A mechanism that cannot fit is evidence about the inherited organization — escalate it.</a:t>
             </a:r>
           </a:p>
         </p:txBody>
@@ -19616,19 +19498,17 @@
         </p:nvSpPr>
         <p:spPr>
           <a:xfrm>
-            <a:off x="700000" y="920000"/>
-            <a:ext cx="4300000" cy="620000"/>
+            <a:off x="2422000" y="1050000"/>
+            <a:ext cx="4300000" cy="700000"/>
           </a:xfrm>
           <a:prstGeom prst="rect">
             <a:avLst/>
           </a:prstGeom>
           <a:solidFill>
-            <a:srgbClr val="F5F1E8"/>
+            <a:srgbClr val="8E6F3E"/>
           </a:solidFill>
-          <a:ln w="12700">
-            <a:solidFill>
-              <a:srgbClr val="C9B991"/>
-            </a:solidFill>
+          <a:ln>
+            <a:noFill/>
           </a:ln>
         </p:spPr>
         <p:txBody>
@@ -19641,10 +19521,26 @@
             <a:r>
               <a:rPr lang="en-US" sz="1800" b="1" i="0" dirty="0">
                 <a:solidFill>
-                  <a:srgbClr val="5C4826"/>
-                </a:solidFill>
-              </a:rPr>
-              <a:t>REQUIREMENTS</a:t>
+                  <a:srgbClr val="FFFFFF"/>
+                </a:solidFill>
+              </a:rPr>
+              <a:t>SPECIFICATION</a:t>
+            </a:r>
+          </a:p>
+          <a:p>
+            <a:pPr algn="ctr">
+              <a:spcBef>
+                <a:spcPts val="60"/>
+              </a:spcBef>
+              <a:buNone/>
+            </a:pPr>
+            <a:r>
+              <a:rPr lang="en-US" sz="1450" b="0" i="1" dirty="0">
+                <a:solidFill>
+                  <a:srgbClr val="FFFFFF"/>
+                </a:solidFill>
+              </a:rPr>
+              <a:t>acceptable realization space</a:t>
             </a:r>
           </a:p>
         </p:txBody>
@@ -19657,8 +19553,8 @@
         </p:nvCxnSpPr>
         <p:spPr>
           <a:xfrm>
-            <a:off x="2850000" y="1550000"/>
-            <a:ext cx="0" cy="200000"/>
+            <a:off x="4572000" y="1750000"/>
+            <a:ext cx="0" cy="500000"/>
           </a:xfrm>
           <a:prstGeom prst="straightConnector1">
             <a:avLst/>
@@ -19679,8 +19575,8 @@
         </p:nvSpPr>
         <p:spPr>
           <a:xfrm>
-            <a:off x="700000" y="1770000"/>
-            <a:ext cx="4300000" cy="620000"/>
+            <a:off x="2422000" y="2250000"/>
+            <a:ext cx="4300000" cy="700000"/>
           </a:xfrm>
           <a:prstGeom prst="rect">
             <a:avLst/>
@@ -19705,7 +19601,7 @@
                   <a:srgbClr val="FFFFFF"/>
                 </a:solidFill>
               </a:rPr>
-              <a:t>SPECIFICATION</a:t>
+              <a:t>ARCHITECTURE</a:t>
             </a:r>
           </a:p>
           <a:p>
@@ -19721,7 +19617,7 @@
                   <a:srgbClr val="FFFFFF"/>
                 </a:solidFill>
               </a:rPr>
-              <a:t>acceptable realization space</a:t>
+              <a:t>coarse parts + constraints</a:t>
             </a:r>
           </a:p>
         </p:txBody>
@@ -19734,8 +19630,8 @@
         </p:nvCxnSpPr>
         <p:spPr>
           <a:xfrm>
-            <a:off x="2850000" y="2400000"/>
-            <a:ext cx="0" cy="200000"/>
+            <a:off x="4572000" y="2950000"/>
+            <a:ext cx="0" cy="500000"/>
           </a:xfrm>
           <a:prstGeom prst="straightConnector1">
             <a:avLst/>
@@ -19756,8 +19652,8 @@
         </p:nvSpPr>
         <p:spPr>
           <a:xfrm>
-            <a:off x="700000" y="2620000"/>
-            <a:ext cx="4300000" cy="620000"/>
+            <a:off x="2422000" y="3450000"/>
+            <a:ext cx="4300000" cy="700000"/>
           </a:xfrm>
           <a:prstGeom prst="rect">
             <a:avLst/>
@@ -19782,7 +19678,7 @@
                   <a:srgbClr val="FFFFFF"/>
                 </a:solidFill>
               </a:rPr>
-              <a:t>ARCHITECTURE</a:t>
+              <a:t>DESIGN</a:t>
             </a:r>
           </a:p>
           <a:p>
@@ -19798,7 +19694,7 @@
                   <a:srgbClr val="FFFFFF"/>
                 </a:solidFill>
               </a:rPr>
-              <a:t>coarse parts + constraints</a:t>
+              <a:t>smaller parts + mechanisms</a:t>
             </a:r>
           </a:p>
         </p:txBody>
@@ -19811,8 +19707,8 @@
         </p:nvCxnSpPr>
         <p:spPr>
           <a:xfrm>
-            <a:off x="2850000" y="3250000"/>
-            <a:ext cx="0" cy="200000"/>
+            <a:off x="4572000" y="4150000"/>
+            <a:ext cx="0" cy="500000"/>
           </a:xfrm>
           <a:prstGeom prst="straightConnector1">
             <a:avLst/>
@@ -19833,8 +19729,8 @@
         </p:nvSpPr>
         <p:spPr>
           <a:xfrm>
-            <a:off x="700000" y="3470000"/>
-            <a:ext cx="4300000" cy="620000"/>
+            <a:off x="2422000" y="4650000"/>
+            <a:ext cx="4300000" cy="700000"/>
           </a:xfrm>
           <a:prstGeom prst="rect">
             <a:avLst/>
@@ -19859,7 +19755,7 @@
                   <a:srgbClr val="FFFFFF"/>
                 </a:solidFill>
               </a:rPr>
-              <a:t>DESIGN</a:t>
+              <a:t>IMPLEMENTATION</a:t>
             </a:r>
           </a:p>
           <a:p>
@@ -19875,177 +19771,21 @@
                   <a:srgbClr val="FFFFFF"/>
                 </a:solidFill>
               </a:rPr>
-              <a:t>smaller parts + mechanisms</a:t>
+              <a:t>directly-reasonable entities</a:t>
             </a:r>
           </a:p>
         </p:txBody>
       </p:sp>
       <p:cxnSp>
         <p:nvCxnSpPr>
-          <p:cNvPr id="107" name="L107"/>
+          <p:cNvPr id="107" name="ConstraintsArrow"/>
           <p:cNvCxnSpPr/>
           <p:nvPr/>
         </p:nvCxnSpPr>
         <p:spPr>
           <a:xfrm>
-            <a:off x="2850000" y="4100000"/>
-            <a:ext cx="0" cy="200000"/>
-          </a:xfrm>
-          <a:prstGeom prst="straightConnector1">
-            <a:avLst/>
-          </a:prstGeom>
-          <a:ln w="38100">
-            <a:solidFill>
-              <a:srgbClr val="8E6F3E"/>
-            </a:solidFill>
-            <a:tailEnd type="triangle" w="med" len="med"/>
-          </a:ln>
-        </p:spPr>
-      </p:cxnSp>
-      <p:sp>
-        <p:nvSpPr>
-          <p:cNvPr id="108" name="S108"/>
-          <p:cNvSpPr/>
-          <p:nvPr/>
-        </p:nvSpPr>
-        <p:spPr>
-          <a:xfrm>
-            <a:off x="700000" y="4320000"/>
-            <a:ext cx="4300000" cy="620000"/>
-          </a:xfrm>
-          <a:prstGeom prst="rect">
-            <a:avLst/>
-          </a:prstGeom>
-          <a:solidFill>
-            <a:srgbClr val="FBF8F2"/>
-          </a:solidFill>
-          <a:ln w="12700">
-            <a:solidFill>
-              <a:srgbClr val="C9B991"/>
-            </a:solidFill>
-          </a:ln>
-        </p:spPr>
-        <p:txBody>
-          <a:bodyPr wrap="square" lIns="91440" tIns="45720" rIns="91440" bIns="45720" anchor="ctr"/>
-          <a:lstStyle/>
-          <a:p>
-            <a:pPr algn="ctr">
-              <a:buNone/>
-            </a:pPr>
-            <a:r>
-              <a:rPr lang="en-US" sz="1800" b="1" i="0" dirty="0">
-                <a:solidFill>
-                  <a:srgbClr val="5C4826"/>
-                </a:solidFill>
-              </a:rPr>
-              <a:t>DESIGN / ARCHITECTURE</a:t>
-            </a:r>
-          </a:p>
-          <a:p>
-            <a:pPr algn="ctr">
-              <a:spcBef>
-                <a:spcPts val="60"/>
-              </a:spcBef>
-              <a:buNone/>
-            </a:pPr>
-            <a:r>
-              <a:rPr lang="en-US" sz="1450" b="0" i="1" dirty="0">
-                <a:solidFill>
-                  <a:srgbClr val="555960"/>
-                </a:solidFill>
-              </a:rPr>
-              <a:t>recurse</a:t>
-            </a:r>
-          </a:p>
-        </p:txBody>
-      </p:sp>
-      <p:cxnSp>
-        <p:nvCxnSpPr>
-          <p:cNvPr id="109" name="L109"/>
-          <p:cNvCxnSpPr/>
-          <p:nvPr/>
-        </p:nvCxnSpPr>
-        <p:spPr>
-          <a:xfrm>
-            <a:off x="2850000" y="4950000"/>
-            <a:ext cx="0" cy="200000"/>
-          </a:xfrm>
-          <a:prstGeom prst="straightConnector1">
-            <a:avLst/>
-          </a:prstGeom>
-          <a:ln w="38100">
-            <a:solidFill>
-              <a:srgbClr val="8E6F3E"/>
-            </a:solidFill>
-            <a:tailEnd type="triangle" w="med" len="med"/>
-          </a:ln>
-        </p:spPr>
-      </p:cxnSp>
-      <p:sp>
-        <p:nvSpPr>
-          <p:cNvPr id="110" name="S110"/>
-          <p:cNvSpPr/>
-          <p:nvPr/>
-        </p:nvSpPr>
-        <p:spPr>
-          <a:xfrm>
-            <a:off x="700000" y="5170000"/>
-            <a:ext cx="4300000" cy="620000"/>
-          </a:xfrm>
-          <a:prstGeom prst="rect">
-            <a:avLst/>
-          </a:prstGeom>
-          <a:solidFill>
-            <a:srgbClr val="8E6F3E"/>
-          </a:solidFill>
-          <a:ln>
-            <a:noFill/>
-          </a:ln>
-        </p:spPr>
-        <p:txBody>
-          <a:bodyPr wrap="square" lIns="91440" tIns="45720" rIns="91440" bIns="45720" anchor="ctr"/>
-          <a:lstStyle/>
-          <a:p>
-            <a:pPr algn="ctr">
-              <a:buNone/>
-            </a:pPr>
-            <a:r>
-              <a:rPr lang="en-US" sz="1800" b="1" i="0" dirty="0">
-                <a:solidFill>
-                  <a:srgbClr val="FFFFFF"/>
-                </a:solidFill>
-              </a:rPr>
-              <a:t>IMPLEMENTATION</a:t>
-            </a:r>
-          </a:p>
-          <a:p>
-            <a:pPr algn="ctr">
-              <a:spcBef>
-                <a:spcPts val="60"/>
-              </a:spcBef>
-              <a:buNone/>
-            </a:pPr>
-            <a:r>
-              <a:rPr lang="en-US" sz="1450" b="0" i="1" dirty="0">
-                <a:solidFill>
-                  <a:srgbClr val="FFFFFF"/>
-                </a:solidFill>
-              </a:rPr>
-              <a:t>directly-reasonable entities</a:t>
-            </a:r>
-          </a:p>
-        </p:txBody>
-      </p:sp>
-      <p:cxnSp>
-        <p:nvCxnSpPr>
-          <p:cNvPr id="111" name="L111"/>
-          <p:cNvCxnSpPr/>
-          <p:nvPr/>
-        </p:nvCxnSpPr>
-        <p:spPr>
-          <a:xfrm flipV="1">
-            <a:off x="5250000" y="1240000"/>
-            <a:ext cx="0" cy="4200000"/>
+            <a:off x="1900000" y="1050000"/>
+            <a:ext cx="0" cy="4300000"/>
           </a:xfrm>
           <a:prstGeom prst="straightConnector1">
             <a:avLst/>
@@ -20060,14 +19800,14 @@
       </p:cxnSp>
       <p:sp>
         <p:nvSpPr>
-          <p:cNvPr id="112" name="Evid"/>
+          <p:cNvPr id="108" name="ConstraintsLbl"/>
           <p:cNvSpPr txBox="1"/>
           <p:nvPr/>
         </p:nvSpPr>
         <p:spPr>
           <a:xfrm>
-            <a:off x="5303520" y="3000000"/>
-            <a:ext cx="1097280" cy="600000"/>
+            <a:off x="350000" y="2950000"/>
+            <a:ext cx="1450000" cy="350000"/>
           </a:xfrm>
           <a:prstGeom prst="rect">
             <a:avLst/>
@@ -20081,7 +19821,7 @@
           <a:bodyPr wrap="square" lIns="0" tIns="0" rIns="0" bIns="0" anchor="t"/>
           <a:lstStyle/>
           <a:p>
-            <a:pPr algn="l">
+            <a:pPr algn="r">
               <a:buNone/>
             </a:pPr>
             <a:r>
@@ -20090,325 +19830,26 @@
                   <a:srgbClr val="8E6F3E"/>
                 </a:solidFill>
               </a:rPr>
-              <a:t>evidence ↑</a:t>
-            </a:r>
-          </a:p>
-        </p:txBody>
-      </p:sp>
-      <p:sp>
-        <p:nvSpPr>
-          <p:cNvPr id="113" name="Sum"/>
-          <p:cNvSpPr txBox="1"/>
-          <p:nvPr/>
-        </p:nvSpPr>
-        <p:spPr>
-          <a:xfrm>
-            <a:off x="6420000" y="1737360"/>
-            <a:ext cx="2620000" cy="900000"/>
-          </a:xfrm>
-          <a:prstGeom prst="rect">
-            <a:avLst/>
-          </a:prstGeom>
-          <a:noFill/>
-          <a:ln>
-            <a:noFill/>
-          </a:ln>
-        </p:spPr>
-        <p:txBody>
-          <a:bodyPr wrap="square" lIns="0" tIns="0" rIns="0" bIns="0" anchor="t"/>
-          <a:lstStyle/>
-          <a:p>
-            <a:pPr algn="l">
-              <a:buNone/>
-            </a:pPr>
-            <a:r>
-              <a:rPr lang="en-US" sz="1900" b="1" i="0" dirty="0">
-                <a:solidFill>
-                  <a:srgbClr val="5C4826"/>
-                </a:solidFill>
-              </a:rPr>
-              <a:t>Specification</a:t>
-            </a:r>
-          </a:p>
-          <a:p>
-            <a:pPr algn="l">
-              <a:spcBef>
-                <a:spcPts val="60"/>
-              </a:spcBef>
-              <a:buNone/>
-            </a:pPr>
-            <a:r>
-              <a:rPr lang="en-US" sz="1600" b="0" i="0" dirty="0">
-                <a:solidFill>
-                  <a:srgbClr val="000000"/>
-                </a:solidFill>
-              </a:rPr>
-              <a:t>constrain what an acceptable system may do</a:t>
-            </a:r>
-          </a:p>
-        </p:txBody>
-      </p:sp>
-      <p:sp>
-        <p:nvSpPr>
-          <p:cNvPr id="114" name="Sum"/>
-          <p:cNvSpPr txBox="1"/>
-          <p:nvPr/>
-        </p:nvSpPr>
-        <p:spPr>
-          <a:xfrm>
-            <a:off x="6420000" y="2587752"/>
-            <a:ext cx="2620000" cy="900000"/>
-          </a:xfrm>
-          <a:prstGeom prst="rect">
-            <a:avLst/>
-          </a:prstGeom>
-          <a:noFill/>
-          <a:ln>
-            <a:noFill/>
-          </a:ln>
-        </p:spPr>
-        <p:txBody>
-          <a:bodyPr wrap="square" lIns="0" tIns="0" rIns="0" bIns="0" anchor="t"/>
-          <a:lstStyle/>
-          <a:p>
-            <a:pPr algn="l">
-              <a:buNone/>
-            </a:pPr>
-            <a:r>
-              <a:rPr lang="en-US" sz="1900" b="1" i="0" dirty="0">
-                <a:solidFill>
-                  <a:srgbClr val="5C4826"/>
-                </a:solidFill>
-              </a:rPr>
-              <a:t>Architecture</a:t>
-            </a:r>
-          </a:p>
-          <a:p>
-            <a:pPr algn="l">
-              <a:spcBef>
-                <a:spcPts val="60"/>
-              </a:spcBef>
-              <a:buNone/>
-            </a:pPr>
-            <a:r>
-              <a:rPr lang="en-US" sz="1600" b="0" i="0" dirty="0">
-                <a:solidFill>
-                  <a:srgbClr val="000000"/>
-                </a:solidFill>
-              </a:rPr>
-              <a:t>choose how an acceptable system is organized</a:t>
-            </a:r>
-          </a:p>
-        </p:txBody>
-      </p:sp>
-      <p:sp>
-        <p:nvSpPr>
-          <p:cNvPr id="115" name="Sum"/>
-          <p:cNvSpPr txBox="1"/>
-          <p:nvPr/>
-        </p:nvSpPr>
-        <p:spPr>
-          <a:xfrm>
-            <a:off x="6420000" y="3429000"/>
-            <a:ext cx="2620000" cy="900000"/>
-          </a:xfrm>
-          <a:prstGeom prst="rect">
-            <a:avLst/>
-          </a:prstGeom>
-          <a:noFill/>
-          <a:ln>
-            <a:noFill/>
-          </a:ln>
-        </p:spPr>
-        <p:txBody>
-          <a:bodyPr wrap="square" lIns="0" tIns="0" rIns="0" bIns="0" anchor="t"/>
-          <a:lstStyle/>
-          <a:p>
-            <a:pPr algn="l">
-              <a:buNone/>
-            </a:pPr>
-            <a:r>
-              <a:rPr lang="en-US" sz="1900" b="1" i="0" dirty="0">
-                <a:solidFill>
-                  <a:srgbClr val="5C4826"/>
-                </a:solidFill>
-              </a:rPr>
-              <a:t>Design</a:t>
-            </a:r>
-          </a:p>
-          <a:p>
-            <a:pPr algn="l">
-              <a:spcBef>
-                <a:spcPts val="60"/>
-              </a:spcBef>
-              <a:buNone/>
-            </a:pPr>
-            <a:r>
-              <a:rPr lang="en-US" sz="1600" b="0" i="0" dirty="0">
-                <a:solidFill>
-                  <a:srgbClr val="000000"/>
-                </a:solidFill>
-              </a:rPr>
-              <a:t>choose how each part realizes its responsibility</a:t>
-            </a:r>
-          </a:p>
-        </p:txBody>
-      </p:sp>
-    </p:spTree>
-  </p:cSld>
-  <p:clrMapOvr>
-    <a:masterClrMapping/>
-  </p:clrMapOvr>
-</p:sld>
-</file>
-
-<file path=ppt/slides/slide36.xml><?xml version="1.0" encoding="utf-8"?>
-<p:sld xmlns:a="http://schemas.openxmlformats.org/drawingml/2006/main" xmlns:p="http://schemas.openxmlformats.org/presentationml/2006/main">
-  <p:cSld>
-    <p:spTree>
-      <p:nvGrpSpPr>
-        <p:cNvPr id="1" name=""/>
-        <p:cNvGrpSpPr/>
-        <p:nvPr/>
-      </p:nvGrpSpPr>
-      <p:grpSpPr>
-        <a:xfrm>
-          <a:off x="0" y="0"/>
-          <a:ext cx="0" cy="0"/>
-          <a:chOff x="0" y="0"/>
-          <a:chExt cx="0" cy="0"/>
-        </a:xfrm>
-      </p:grpSpPr>
-      <p:sp>
-        <p:nvSpPr>
-          <p:cNvPr id="2" name="Title 1"/>
-          <p:cNvSpPr>
-            <a:spLocks noGrp="1"/>
-          </p:cNvSpPr>
-          <p:nvPr>
-            <p:ph type="title"/>
-          </p:nvPr>
-        </p:nvSpPr>
-        <p:spPr>
-          <a:xfrm>
-            <a:off x="277148" y="118428"/>
-            <a:ext cx="8590000" cy="638175"/>
-          </a:xfrm>
-        </p:spPr>
-        <p:txBody>
-          <a:bodyPr>
-            <a:normAutofit fontScale="90000"/>
-          </a:bodyPr>
-          <a:lstStyle/>
-          <a:p>
-            <a:pPr>
-              <a:buNone/>
-              <a:defRPr b="0"/>
-            </a:pPr>
-            <a:r>
-              <a:rPr lang="en-US" sz="2400" b="0" i="0" dirty="0">
-                <a:solidFill>
-                  <a:srgbClr val="000000"/>
-                </a:solidFill>
-              </a:rPr>
-              <a:t>What Design does</a:t>
-            </a:r>
-          </a:p>
-        </p:txBody>
-      </p:sp>
-      <p:sp>
-        <p:nvSpPr>
-          <p:cNvPr id="3" name="Slide Number Placeholder 3"/>
-          <p:cNvSpPr>
-            <a:spLocks noGrp="1"/>
-          </p:cNvSpPr>
-          <p:nvPr>
-            <p:ph type="sldNum" sz="quarter" idx="4"/>
-          </p:nvPr>
-        </p:nvSpPr>
-        <p:spPr/>
-        <p:txBody>
-          <a:bodyPr/>
-          <a:lstStyle/>
-          <a:p>
-            <a:fld id="{B7EB45DA-9A0D-DC49-8E02-F30A5DDC21C3}" type="slidenum">
-              <a:rPr lang="en-US" smtClean="0"/>
-              <a:t>1</a:t>
-            </a:fld>
-            <a:endParaRPr lang="en-US"/>
-          </a:p>
-        </p:txBody>
-      </p:sp>
-      <p:sp>
-        <p:nvSpPr>
-          <p:cNvPr id="100" name="S100"/>
-          <p:cNvSpPr/>
-          <p:nvPr/>
-        </p:nvSpPr>
-        <p:spPr>
-          <a:xfrm>
-            <a:off x="2592000" y="1005184"/>
-            <a:ext cx="3960000" cy="813600"/>
-          </a:xfrm>
-          <a:prstGeom prst="rect">
-            <a:avLst/>
-          </a:prstGeom>
-          <a:solidFill>
-            <a:srgbClr val="8E6F3E"/>
-          </a:solidFill>
-          <a:ln>
-            <a:noFill/>
-          </a:ln>
-        </p:spPr>
-        <p:txBody>
-          <a:bodyPr wrap="square" lIns="91440" tIns="45720" rIns="91440" bIns="45720" anchor="ctr"/>
-          <a:lstStyle/>
-          <a:p>
-            <a:pPr algn="ctr">
-              <a:buNone/>
-            </a:pPr>
-            <a:r>
-              <a:rPr lang="en-US" sz="2400" b="1" i="0" dirty="0">
-                <a:solidFill>
-                  <a:srgbClr val="FFFFFF"/>
-                </a:solidFill>
-              </a:rPr>
-              <a:t>ARCHITECTURE</a:t>
-            </a:r>
-          </a:p>
-          <a:p>
-            <a:pPr algn="ctr">
-              <a:spcBef>
-                <a:spcPts val="60"/>
-              </a:spcBef>
-              <a:buNone/>
-            </a:pPr>
-            <a:r>
-              <a:rPr lang="en-US" sz="1800" b="0" i="1" dirty="0">
-                <a:solidFill>
-                  <a:srgbClr val="FFFFFF"/>
-                </a:solidFill>
-              </a:rPr>
-              <a:t>strategy</a:t>
+              <a:t>constraints ↓</a:t>
             </a:r>
           </a:p>
         </p:txBody>
       </p:sp>
       <p:cxnSp>
         <p:nvCxnSpPr>
-          <p:cNvPr id="101" name="L101"/>
+          <p:cNvPr id="109" name="EvidenceArrow"/>
           <p:cNvCxnSpPr/>
           <p:nvPr/>
         </p:nvCxnSpPr>
         <p:spPr>
-          <a:xfrm>
-            <a:off x="4572000" y="1841384"/>
-            <a:ext cx="0" cy="293800"/>
+          <a:xfrm flipV="1">
+            <a:off x="7244000" y="1050000"/>
+            <a:ext cx="0" cy="4300000"/>
           </a:xfrm>
           <a:prstGeom prst="straightConnector1">
             <a:avLst/>
           </a:prstGeom>
-          <a:ln w="38100">
+          <a:ln w="25400">
             <a:solidFill>
               <a:srgbClr val="8E6F3E"/>
             </a:solidFill>
@@ -20418,14 +19859,14 @@
       </p:cxnSp>
       <p:sp>
         <p:nvSpPr>
-          <p:cNvPr id="102" name="CA"/>
+          <p:cNvPr id="110" name="EvidenceLbl"/>
           <p:cNvSpPr txBox="1"/>
           <p:nvPr/>
         </p:nvSpPr>
         <p:spPr>
           <a:xfrm>
-            <a:off x="274320" y="2157784"/>
-            <a:ext cx="8595360" cy="361599"/>
+            <a:off x="7360000" y="2600000"/>
+            <a:ext cx="1500000" cy="350000"/>
           </a:xfrm>
           <a:prstGeom prst="rect">
             <a:avLst/>
@@ -20439,131 +19880,30 @@
           <a:bodyPr wrap="square" lIns="0" tIns="0" rIns="0" bIns="0" anchor="t"/>
           <a:lstStyle/>
           <a:p>
-            <a:pPr algn="ctr">
-              <a:buNone/>
-            </a:pPr>
-            <a:r>
-              <a:rPr lang="en-US" sz="2000" b="0" i="1" dirty="0">
-                <a:solidFill>
-                  <a:srgbClr val="555960"/>
-                </a:solidFill>
-              </a:rPr>
-              <a:t>constraints · affordances</a:t>
-            </a:r>
-          </a:p>
-        </p:txBody>
-      </p:sp>
-      <p:cxnSp>
-        <p:nvCxnSpPr>
-          <p:cNvPr id="103" name="L103"/>
-          <p:cNvCxnSpPr/>
-          <p:nvPr/>
-        </p:nvCxnSpPr>
-        <p:spPr>
-          <a:xfrm>
-            <a:off x="4572000" y="2541984"/>
-            <a:ext cx="0" cy="293800"/>
-          </a:xfrm>
-          <a:prstGeom prst="straightConnector1">
-            <a:avLst/>
-          </a:prstGeom>
-          <a:ln w="38100">
-            <a:solidFill>
-              <a:srgbClr val="8E6F3E"/>
-            </a:solidFill>
-            <a:tailEnd type="triangle" w="med" len="med"/>
-          </a:ln>
-        </p:spPr>
-      </p:cxnSp>
-      <p:sp>
-        <p:nvSpPr>
-          <p:cNvPr id="104" name="S104"/>
-          <p:cNvSpPr/>
-          <p:nvPr/>
-        </p:nvSpPr>
-        <p:spPr>
-          <a:xfrm>
-            <a:off x="2592000" y="2858384"/>
-            <a:ext cx="3960000" cy="813600"/>
-          </a:xfrm>
-          <a:prstGeom prst="rect">
-            <a:avLst/>
-          </a:prstGeom>
-          <a:solidFill>
-            <a:srgbClr val="F5F1E8"/>
-          </a:solidFill>
-          <a:ln w="19050">
-            <a:solidFill>
-              <a:srgbClr val="5C4826"/>
-            </a:solidFill>
-          </a:ln>
-        </p:spPr>
-        <p:txBody>
-          <a:bodyPr wrap="square" lIns="91440" tIns="45720" rIns="91440" bIns="45720" anchor="ctr"/>
-          <a:lstStyle/>
-          <a:p>
-            <a:pPr algn="ctr">
-              <a:buNone/>
-            </a:pPr>
-            <a:r>
-              <a:rPr lang="en-US" sz="2400" b="1" i="0" dirty="0">
-                <a:solidFill>
-                  <a:srgbClr val="5C4826"/>
-                </a:solidFill>
-              </a:rPr>
-              <a:t>DESIGN</a:t>
-            </a:r>
-          </a:p>
-          <a:p>
-            <a:pPr algn="ctr">
-              <a:spcBef>
-                <a:spcPts val="60"/>
-              </a:spcBef>
-              <a:buNone/>
-            </a:pPr>
-            <a:r>
-              <a:rPr lang="en-US" sz="1800" b="0" i="1" dirty="0">
-                <a:solidFill>
-                  <a:srgbClr val="5C4826"/>
-                </a:solidFill>
-              </a:rPr>
-              <a:t>tactics</a:t>
-            </a:r>
-          </a:p>
-        </p:txBody>
-      </p:sp>
-      <p:cxnSp>
-        <p:nvCxnSpPr>
-          <p:cNvPr id="105" name="L105"/>
-          <p:cNvCxnSpPr/>
-          <p:nvPr/>
-        </p:nvCxnSpPr>
-        <p:spPr>
-          <a:xfrm>
-            <a:off x="4572000" y="3694584"/>
-            <a:ext cx="0" cy="293800"/>
-          </a:xfrm>
-          <a:prstGeom prst="straightConnector1">
-            <a:avLst/>
-          </a:prstGeom>
-          <a:ln w="38100">
-            <a:solidFill>
-              <a:srgbClr val="8E6F3E"/>
-            </a:solidFill>
-            <a:tailEnd type="triangle" w="med" len="med"/>
-          </a:ln>
-        </p:spPr>
-      </p:cxnSp>
-      <p:sp>
-        <p:nvSpPr>
-          <p:cNvPr id="106" name="Ev"/>
+            <a:pPr algn="l">
+              <a:buNone/>
+            </a:pPr>
+            <a:r>
+              <a:rPr lang="en-US" sz="1450" b="1" i="1" dirty="0">
+                <a:solidFill>
+                  <a:srgbClr val="8E6F3E"/>
+                </a:solidFill>
+              </a:rPr>
+              <a:t>evidence ↑</a:t>
+            </a:r>
+          </a:p>
+        </p:txBody>
+      </p:sp>
+      <p:sp>
+        <p:nvSpPr>
+          <p:cNvPr id="111" name="SideAnnotation"/>
           <p:cNvSpPr txBox="1"/>
           <p:nvPr/>
         </p:nvSpPr>
         <p:spPr>
           <a:xfrm>
-            <a:off x="274320" y="4010984"/>
-            <a:ext cx="8595360" cy="361599"/>
+            <a:off x="7360000" y="3050000"/>
+            <a:ext cx="1550000" cy="1500000"/>
           </a:xfrm>
           <a:prstGeom prst="rect">
             <a:avLst/>
@@ -20577,116 +19917,20 @@
           <a:bodyPr wrap="square" lIns="0" tIns="0" rIns="0" bIns="0" anchor="t"/>
           <a:lstStyle/>
           <a:p>
-            <a:pPr algn="ctr">
-              <a:buNone/>
-            </a:pPr>
-            <a:r>
-              <a:rPr lang="en-US" sz="2000" b="0" i="1" dirty="0">
-                <a:solidFill>
-                  <a:srgbClr val="8E6F3E"/>
-                </a:solidFill>
-              </a:rPr>
-              <a:t>evidence</a:t>
-            </a:r>
-          </a:p>
-        </p:txBody>
-      </p:sp>
-      <p:cxnSp>
-        <p:nvCxnSpPr>
-          <p:cNvPr id="107" name="L107"/>
-          <p:cNvCxnSpPr/>
-          <p:nvPr/>
-        </p:nvCxnSpPr>
-        <p:spPr>
-          <a:xfrm>
-            <a:off x="6552000" y="1411984"/>
-            <a:ext cx="250800" cy="2960599"/>
-          </a:xfrm>
-          <a:prstGeom prst="bentConnector2">
-            <a:avLst/>
-          </a:prstGeom>
-          <a:ln w="25400">
-            <a:solidFill>
-              <a:srgbClr val="8E6F3E"/>
-            </a:solidFill>
-            <a:headEnd type="triangle" w="med" len="med"/>
-          </a:ln>
-        </p:spPr>
-      </p:cxnSp>
-      <p:sp>
-        <p:nvSpPr>
-          <p:cNvPr id="108" name="Final"/>
-          <p:cNvSpPr txBox="1"/>
-          <p:nvPr/>
-        </p:nvSpPr>
-        <p:spPr>
-          <a:xfrm>
-            <a:off x="277148" y="4892040"/>
-            <a:ext cx="8589704" cy="1188720"/>
-          </a:xfrm>
-          <a:prstGeom prst="rect">
-            <a:avLst/>
-          </a:prstGeom>
-          <a:noFill/>
-          <a:ln>
-            <a:noFill/>
-          </a:ln>
-        </p:spPr>
-        <p:txBody>
-          <a:bodyPr wrap="square" lIns="0" tIns="0" rIns="0" bIns="0" anchor="t"/>
-          <a:lstStyle/>
-          <a:p>
-            <a:pPr algn="ctr">
-              <a:buNone/>
-            </a:pPr>
-            <a:r>
-              <a:rPr lang="en-US" sz="2800" b="1" i="0" dirty="0">
-                <a:solidFill>
-                  <a:srgbClr val="000000"/>
-                </a:solidFill>
-              </a:rPr>
-              <a:t>Architecture constrains the available tactics.</a:t>
-            </a:r>
-          </a:p>
-          <a:p>
-            <a:pPr algn="ctr">
-              <a:spcBef>
-                <a:spcPts val="140"/>
-              </a:spcBef>
-              <a:buNone/>
-            </a:pPr>
-            <a:r>
-              <a:rPr lang="en-US" sz="2800" b="1" i="0" dirty="0">
-                <a:solidFill>
-                  <a:srgbClr val="000000"/>
-                </a:solidFill>
-              </a:rPr>
-              <a:t>Design tests whether the strategy is workable.</a:t>
-            </a:r>
-          </a:p>
-        </p:txBody>
-      </p:sp>
-      <p:cxnSp>
-        <p:nvCxnSpPr>
-          <p:cNvPr id="220" name="LoopHoriz"/>
-          <p:cNvCxnSpPr/>
-          <p:nvPr/>
-        </p:nvCxnSpPr>
-        <p:spPr>
-          <a:xfrm>
-            <a:off x="5350000" y="4372583"/>
-            <a:ext cx="1452800" cy="0"/>
-          </a:xfrm>
-          <a:prstGeom prst="straightConnector1">
-            <a:avLst/>
-          </a:prstGeom>
-          <a:ln w="28575">
-            <a:solidFill>
-              <a:srgbClr val="8E6F3E"/>
-            </a:solidFill>
-          </a:ln>
-        </p:spPr>
-      </p:cxnSp>
+            <a:pPr algn="l">
+              <a:buNone/>
+            </a:pPr>
+            <a:r>
+              <a:rPr lang="en-US" sz="1150" b="0" i="1" dirty="0">
+                <a:solidFill>
+                  <a:srgbClr val="555960"/>
+                </a:solidFill>
+              </a:rPr>
+              <a:t>evidence may revise Design, Architecture, the Engineering Environment, or Specification</a:t>
+            </a:r>
+          </a:p>
+        </p:txBody>
+      </p:sp>
     </p:spTree>
   </p:cSld>
   <p:clrMapOvr>
@@ -21692,8 +20936,8 @@
         </p:nvSpPr>
         <p:spPr>
           <a:xfrm>
-            <a:off x="685800" y="2240280"/>
-            <a:ext cx="7772400" cy="914400"/>
+            <a:off x="685800" y="2140000"/>
+            <a:ext cx="7772400" cy="1450000"/>
           </a:xfrm>
         </p:spPr>
         <p:txBody>
@@ -21707,12 +20951,12 @@
               <a:defRPr b="0"/>
             </a:pPr>
             <a:r>
-              <a:rPr lang="en-US" sz="3600" b="0" i="0" dirty="0">
+              <a:rPr lang="en-US" sz="3200" b="0" i="0" dirty="0">
                 <a:solidFill>
                   <a:srgbClr val="000000"/>
                 </a:solidFill>
               </a:rPr>
-              <a:t>How do local decisions affect the system?</a:t>
+              <a:t>Can a system of correct components still fail to satisfy its specification?</a:t>
             </a:r>
           </a:p>
         </p:txBody>
@@ -21785,7 +21029,7 @@
         </p:nvSpPr>
         <p:spPr>
           <a:xfrm>
-            <a:off x="3429000" y="3383280"/>
+            <a:off x="3429000" y="3720000"/>
             <a:ext cx="2286000" cy="50800"/>
           </a:xfrm>
           <a:prstGeom prst="rect">
@@ -21808,14 +21052,14 @@
       </p:sp>
       <p:sp>
         <p:nvSpPr>
-          <p:cNvPr id="102" name="Subtitle"/>
+          <p:cNvPr id="102" name="AssumeLine"/>
           <p:cNvSpPr txBox="1"/>
           <p:nvPr/>
         </p:nvSpPr>
         <p:spPr>
           <a:xfrm>
-            <a:off x="685800" y="3794760"/>
-            <a:ext cx="7772400" cy="1920240"/>
+            <a:off x="685800" y="3960000"/>
+            <a:ext cx="7772400" cy="420000"/>
           </a:xfrm>
           <a:prstGeom prst="rect">
             <a:avLst/>
@@ -21833,44 +21077,104 @@
               <a:buNone/>
             </a:pPr>
             <a:r>
-              <a:rPr lang="en-US" sz="3300" b="0" i="0" dirty="0">
+              <a:rPr lang="en-US" sz="2000" b="0" i="1" dirty="0">
                 <a:solidFill>
                   <a:srgbClr val="555960"/>
                 </a:solidFill>
               </a:rPr>
-              <a:t>Individually sound choices</a:t>
+              <a:t>Assume every component correctly fulfills its local responsibility.</a:t>
+            </a:r>
+          </a:p>
+        </p:txBody>
+      </p:sp>
+      <p:sp>
+        <p:nvSpPr>
+          <p:cNvPr id="103" name="TpsChip"/>
+          <p:cNvSpPr/>
+          <p:nvPr/>
+        </p:nvSpPr>
+        <p:spPr>
+          <a:xfrm>
+            <a:off x="3582000" y="4620000"/>
+            <a:ext cx="1980000" cy="330000"/>
+          </a:xfrm>
+          <a:prstGeom prst="roundRect">
+            <a:avLst/>
+          </a:prstGeom>
+          <a:solidFill>
+            <a:srgbClr val="8E6F3E"/>
+          </a:solidFill>
+          <a:ln>
+            <a:noFill/>
+          </a:ln>
+        </p:spPr>
+        <p:txBody>
+          <a:bodyPr wrap="square" lIns="45720" tIns="0" rIns="45720" bIns="0" anchor="ctr"/>
+          <a:lstStyle/>
+          <a:p>
+            <a:pPr algn="ctr">
+              <a:buNone/>
+            </a:pPr>
+            <a:r>
+              <a:rPr lang="en-US" sz="1200" b="1" i="0" dirty="0">
+                <a:solidFill>
+                  <a:srgbClr val="FFFFFF"/>
+                </a:solidFill>
+              </a:rPr>
+              <a:t>THINK · PAIR · SHARE</a:t>
+            </a:r>
+          </a:p>
+        </p:txBody>
+      </p:sp>
+      <p:sp>
+        <p:nvSpPr>
+          <p:cNvPr id="104" name="TaskLine"/>
+          <p:cNvSpPr txBox="1"/>
+          <p:nvPr/>
+        </p:nvSpPr>
+        <p:spPr>
+          <a:xfrm>
+            <a:off x="685800" y="5150000"/>
+            <a:ext cx="7772400" cy="700000"/>
+          </a:xfrm>
+          <a:prstGeom prst="rect">
+            <a:avLst/>
+          </a:prstGeom>
+          <a:noFill/>
+          <a:ln>
+            <a:noFill/>
+          </a:ln>
+        </p:spPr>
+        <p:txBody>
+          <a:bodyPr wrap="square" lIns="0" tIns="0" rIns="0" bIns="0" anchor="t"/>
+          <a:lstStyle/>
+          <a:p>
+            <a:pPr algn="ctr">
+              <a:buNone/>
+            </a:pPr>
+            <a:r>
+              <a:rPr lang="en-US" sz="1800" b="0" i="0" dirty="0">
+                <a:solidFill>
+                  <a:srgbClr val="5C4826"/>
+                </a:solidFill>
+              </a:rPr>
+              <a:t>Yes or no? Construct an example or argument.</a:t>
             </a:r>
           </a:p>
           <a:p>
             <a:pPr algn="ctr">
               <a:spcBef>
-                <a:spcPts val="120"/>
+                <a:spcPts val="80"/>
               </a:spcBef>
               <a:buNone/>
             </a:pPr>
             <a:r>
-              <a:rPr lang="en-US" sz="3300" b="0" i="0" dirty="0">
+              <a:rPr lang="en-US" sz="1300" b="0" i="1" dirty="0">
                 <a:solidFill>
                   <a:srgbClr val="555960"/>
                 </a:solidFill>
               </a:rPr>
-              <a:t>can compose into</a:t>
-            </a:r>
-          </a:p>
-          <a:p>
-            <a:pPr algn="ctr">
-              <a:spcBef>
-                <a:spcPts val="120"/>
-              </a:spcBef>
-              <a:buNone/>
-            </a:pPr>
-            <a:r>
-              <a:rPr lang="en-US" sz="3300" b="0" i="0" dirty="0">
-                <a:solidFill>
-                  <a:srgbClr val="555960"/>
-                </a:solidFill>
-              </a:rPr>
-              <a:t>an unsound system.</a:t>
+              <a:t>~2 minutes.</a:t>
             </a:r>
           </a:p>
         </p:txBody>
@@ -25126,12 +24430,25 @@
               <a:buNone/>
             </a:pPr>
             <a:r>
+              <a:rPr lang="en-US" sz="1000" b="1" i="0" dirty="0">
+                <a:solidFill>
+                  <a:srgbClr val="8E6F3E"/>
+                </a:solidFill>
+              </a:rPr>
+              <a:t>A</a:t>
+            </a:r>
+          </a:p>
+          <a:p>
+            <a:pPr algn="ctr">
+              <a:buNone/>
+            </a:pPr>
+            <a:r>
               <a:rPr lang="en-US" sz="1200" b="1" i="0" dirty="0">
                 <a:solidFill>
                   <a:srgbClr val="5C4826"/>
                 </a:solidFill>
               </a:rPr>
-              <a:t>400</a:t>
+              <a:t>90 ✓</a:t>
             </a:r>
           </a:p>
         </p:txBody>
@@ -25167,12 +24484,25 @@
               <a:buNone/>
             </a:pPr>
             <a:r>
+              <a:rPr lang="en-US" sz="1000" b="1" i="0" dirty="0">
+                <a:solidFill>
+                  <a:srgbClr val="8E6F3E"/>
+                </a:solidFill>
+              </a:rPr>
+              <a:t>B</a:t>
+            </a:r>
+          </a:p>
+          <a:p>
+            <a:pPr algn="ctr">
+              <a:buNone/>
+            </a:pPr>
+            <a:r>
               <a:rPr lang="en-US" sz="1200" b="1" i="0" dirty="0">
                 <a:solidFill>
                   <a:srgbClr val="5C4826"/>
                 </a:solidFill>
               </a:rPr>
-              <a:t>400</a:t>
+              <a:t>80 ✓</a:t>
             </a:r>
           </a:p>
         </p:txBody>
@@ -25208,12 +24538,25 @@
               <a:buNone/>
             </a:pPr>
             <a:r>
+              <a:rPr lang="en-US" sz="1000" b="1" i="0" dirty="0">
+                <a:solidFill>
+                  <a:srgbClr val="8E6F3E"/>
+                </a:solidFill>
+              </a:rPr>
+              <a:t>C</a:t>
+            </a:r>
+          </a:p>
+          <a:p>
+            <a:pPr algn="ctr">
+              <a:buNone/>
+            </a:pPr>
+            <a:r>
               <a:rPr lang="en-US" sz="1200" b="1" i="0" dirty="0">
                 <a:solidFill>
                   <a:srgbClr val="5C4826"/>
                 </a:solidFill>
               </a:rPr>
-              <a:t>400</a:t>
+              <a:t>140 ✓</a:t>
             </a:r>
           </a:p>
         </p:txBody>
@@ -25249,12 +24592,25 @@
               <a:buNone/>
             </a:pPr>
             <a:r>
+              <a:rPr lang="en-US" sz="1000" b="1" i="0" dirty="0">
+                <a:solidFill>
+                  <a:srgbClr val="8E6F3E"/>
+                </a:solidFill>
+              </a:rPr>
+              <a:t>D</a:t>
+            </a:r>
+          </a:p>
+          <a:p>
+            <a:pPr algn="ctr">
+              <a:buNone/>
+            </a:pPr>
+            <a:r>
               <a:rPr lang="en-US" sz="1200" b="1" i="0" dirty="0">
                 <a:solidFill>
                   <a:srgbClr val="5C4826"/>
                 </a:solidFill>
               </a:rPr>
-              <a:t>400</a:t>
+              <a:t>110 ✓</a:t>
             </a:r>
           </a:p>
         </p:txBody>
@@ -25290,12 +24646,25 @@
               <a:buNone/>
             </a:pPr>
             <a:r>
+              <a:rPr lang="en-US" sz="1000" b="1" i="0" dirty="0">
+                <a:solidFill>
+                  <a:srgbClr val="8E6F3E"/>
+                </a:solidFill>
+              </a:rPr>
+              <a:t>E</a:t>
+            </a:r>
+          </a:p>
+          <a:p>
+            <a:pPr algn="ctr">
+              <a:buNone/>
+            </a:pPr>
+            <a:r>
               <a:rPr lang="en-US" sz="1200" b="1" i="0" dirty="0">
                 <a:solidFill>
                   <a:srgbClr val="5C4826"/>
                 </a:solidFill>
               </a:rPr>
-              <a:t>400</a:t>
+              <a:t>100 ✓</a:t>
             </a:r>
           </a:p>
         </p:txBody>
@@ -25332,7 +24701,7 @@
                   <a:srgbClr val="555960"/>
                 </a:solidFill>
               </a:rPr>
-              <a:t>five components, each within its own 400 ms bar</a:t>
+              <a:t>five components, each locally reasonable (each ✓)</a:t>
             </a:r>
           </a:p>
         </p:txBody>
@@ -25369,7 +24738,76 @@
                   <a:srgbClr val="C0392B"/>
                 </a:solidFill>
               </a:rPr>
-              <a:t>= 2,000 ms on the path  ✗</a:t>
+              <a:t>PATH = 520 ms  ✗</a:t>
+            </a:r>
+          </a:p>
+        </p:txBody>
+      </p:sp>
+      <p:sp>
+        <p:nvSpPr>
+          <p:cNvPr id="111" name="MetricCalloutL"/>
+          <p:cNvSpPr txBox="1"/>
+          <p:nvPr/>
+        </p:nvSpPr>
+        <p:spPr>
+          <a:xfrm>
+            <a:off x="462799" y="3720000"/>
+            <a:ext cx="3660000" cy="520000"/>
+          </a:xfrm>
+          <a:prstGeom prst="rect">
+            <a:avLst/>
+          </a:prstGeom>
+          <a:noFill/>
+          <a:ln>
+            <a:noFill/>
+          </a:ln>
+        </p:spPr>
+        <p:txBody>
+          <a:bodyPr wrap="square" lIns="0" tIns="0" rIns="0" bIns="0" anchor="t"/>
+          <a:lstStyle/>
+          <a:p>
+            <a:pPr algn="ctr">
+              <a:buNone/>
+            </a:pPr>
+            <a:r>
+              <a:rPr lang="en-US" sz="1100" b="1" i="0" dirty="0">
+                <a:solidFill>
+                  <a:srgbClr val="8E6F3E"/>
+                </a:solidFill>
+              </a:rPr>
+              <a:t xml:space="preserve">local evidence: </a:t>
+            </a:r>
+            <a:r>
+              <a:rPr lang="en-US" sz="1100" b="0" i="0" dirty="0">
+                <a:solidFill>
+                  <a:srgbClr val="555960"/>
+                </a:solidFill>
+              </a:rPr>
+              <a:t>component latency</a:t>
+            </a:r>
+          </a:p>
+          <a:p>
+            <a:pPr algn="ctr">
+              <a:spcBef>
+                <a:spcPts val="40"/>
+              </a:spcBef>
+              <a:buNone/>
+            </a:pPr>
+            <a:r>
+              <a:rPr lang="en-US" sz="1100" b="1" i="0" dirty="0">
+                <a:solidFill>
+                  <a:srgbClr val="8E6F3E"/>
+                </a:solidFill>
+              </a:rPr>
+              <a:t xml:space="preserve">system claim: </a:t>
+            </a:r>
+            <a:r>
+              <a:rPr lang="en-US" sz="1100" b="0" i="0" dirty="0">
+                <a:solidFill>
+                  <a:srgbClr val="555960"/>
+                </a:solidFill>
+              </a:rPr>
+              <a:t>end-to-end latency</a:t>
             </a:r>
           </a:p>
         </p:txBody>
@@ -25493,7 +24931,7 @@
         </p:nvSpPr>
         <p:spPr>
           <a:xfrm>
-            <a:off x="5100000" y="1900000"/>
+            <a:off x="4960000" y="1900000"/>
             <a:ext cx="1600000" cy="900000"/>
           </a:xfrm>
           <a:prstGeom prst="rect">
@@ -25547,7 +24985,7 @@
         </p:nvSpPr>
         <p:spPr>
           <a:xfrm>
-            <a:off x="7000000" y="1900000"/>
+            <a:off x="7140000" y="1900000"/>
             <a:ext cx="1600000" cy="900000"/>
           </a:xfrm>
           <a:prstGeom prst="rect">
@@ -25601,8 +25039,8 @@
         </p:nvSpPr>
         <p:spPr>
           <a:xfrm>
-            <a:off x="6700000" y="1900000"/>
-            <a:ext cx="300000" cy="900000"/>
+            <a:off x="6620000" y="1900000"/>
+            <a:ext cx="460000" cy="900000"/>
           </a:xfrm>
           <a:prstGeom prst="rect">
             <a:avLst/>
@@ -25649,6 +25087,75 @@
                 </a:solidFill>
               </a:rPr>
               <a:t>the sanitization obligation is unowned  ✗</a:t>
+            </a:r>
+          </a:p>
+        </p:txBody>
+      </p:sp>
+      <p:sp>
+        <p:nvSpPr>
+          <p:cNvPr id="127" name="MetricCalloutR"/>
+          <p:cNvSpPr txBox="1"/>
+          <p:nvPr/>
+        </p:nvSpPr>
+        <p:spPr>
+          <a:xfrm>
+            <a:off x="5100000" y="3680000"/>
+            <a:ext cx="3500000" cy="580000"/>
+          </a:xfrm>
+          <a:prstGeom prst="rect">
+            <a:avLst/>
+          </a:prstGeom>
+          <a:noFill/>
+          <a:ln>
+            <a:noFill/>
+          </a:ln>
+        </p:spPr>
+        <p:txBody>
+          <a:bodyPr wrap="square" lIns="0" tIns="0" rIns="0" bIns="0" anchor="t"/>
+          <a:lstStyle/>
+          <a:p>
+            <a:pPr algn="ctr">
+              <a:buNone/>
+            </a:pPr>
+            <a:r>
+              <a:rPr lang="en-US" sz="1100" b="1" i="0" dirty="0">
+                <a:solidFill>
+                  <a:srgbClr val="8E6F3E"/>
+                </a:solidFill>
+              </a:rPr>
+              <a:t xml:space="preserve">local evidence: </a:t>
+            </a:r>
+            <a:r>
+              <a:rPr lang="en-US" sz="1100" b="0" i="0" dirty="0">
+                <a:solidFill>
+                  <a:srgbClr val="555960"/>
+                </a:solidFill>
+              </a:rPr>
+              <a:t>each part obeys its assumed contract</a:t>
+            </a:r>
+          </a:p>
+          <a:p>
+            <a:pPr algn="ctr">
+              <a:spcBef>
+                <a:spcPts val="40"/>
+              </a:spcBef>
+              <a:buNone/>
+            </a:pPr>
+            <a:r>
+              <a:rPr lang="en-US" sz="1100" b="1" i="0" dirty="0">
+                <a:solidFill>
+                  <a:srgbClr val="8E6F3E"/>
+                </a:solidFill>
+              </a:rPr>
+              <a:t xml:space="preserve">system claim: </a:t>
+            </a:r>
+            <a:r>
+              <a:rPr lang="en-US" sz="1100" b="0" i="0" dirty="0">
+                <a:solidFill>
+                  <a:srgbClr val="555960"/>
+                </a:solidFill>
+              </a:rPr>
+              <a:t>the sanitization obligation is covered</a:t>
             </a:r>
           </a:p>
         </p:txBody>
@@ -25799,7 +25306,7 @@
                   <a:srgbClr val="000000"/>
                 </a:solidFill>
               </a:rPr>
-              <a:t>Locally correct, globally wrong</a:t>
+              <a:t>What must compose?</a:t>
             </a:r>
           </a:p>
         </p:txBody>
@@ -25829,120 +25336,14 @@
       </p:sp>
       <p:sp>
         <p:nvSpPr>
-          <p:cNvPr id="100" name="TpsBox"/>
+          <p:cNvPr id="300" name="Check1"/>
           <p:cNvSpPr/>
           <p:nvPr/>
         </p:nvSpPr>
         <p:spPr>
           <a:xfrm>
-            <a:off x="274320" y="1000000"/>
-            <a:ext cx="8595360" cy="1900000"/>
-          </a:xfrm>
-          <a:prstGeom prst="rect">
-            <a:avLst/>
-          </a:prstGeom>
-          <a:solidFill>
-            <a:srgbClr val="FBF8F2"/>
-          </a:solidFill>
-          <a:ln w="15875">
-            <a:solidFill>
-              <a:srgbClr val="8E6F3E"/>
-            </a:solidFill>
-          </a:ln>
-        </p:spPr>
-        <p:txBody>
-          <a:bodyPr wrap="square" lIns="91440" tIns="45720" rIns="91440" bIns="45720" anchor="ctr"/>
-          <a:lstStyle/>
-          <a:p>
-            <a:pPr algn="ctr">
-              <a:buNone/>
-            </a:pPr>
-            <a:r>
-              <a:rPr lang="en-US" sz="2000" b="1" i="0" dirty="0">
-                <a:solidFill>
-                  <a:srgbClr val="5C4826"/>
-                </a:solidFill>
-              </a:rPr>
-              <a:t>Every part passed its local tests. The system still fails its specification.</a:t>
-            </a:r>
-          </a:p>
-          <a:p>
-            <a:pPr algn="ctr">
-              <a:buNone/>
-            </a:pPr>
-            <a:r>
-              <a:rPr lang="en-US" sz="1800" b="0" i="0" dirty="0">
-                <a:solidFill>
-                  <a:srgbClr val="5C4826"/>
-                </a:solidFill>
-              </a:rPr>
-              <a:t>What questions would you ask to find out why?</a:t>
-            </a:r>
-          </a:p>
-          <a:p>
-            <a:pPr algn="ctr">
-              <a:buNone/>
-            </a:pPr>
-            <a:r>
-              <a:rPr lang="en-US" sz="1300" b="0" i="1" dirty="0">
-                <a:solidFill>
-                  <a:srgbClr val="555960"/>
-                </a:solidFill>
-              </a:rPr>
-              <a:t>~3 minutes. Write at least three.</a:t>
-            </a:r>
-          </a:p>
-        </p:txBody>
-      </p:sp>
-      <p:sp>
-        <p:nvSpPr>
-          <p:cNvPr id="101" name="TpsChip"/>
-          <p:cNvSpPr/>
-          <p:nvPr/>
-        </p:nvSpPr>
-        <p:spPr>
-          <a:xfrm>
-            <a:off x="460000" y="1150000"/>
-            <a:ext cx="1980000" cy="330000"/>
-          </a:xfrm>
-          <a:prstGeom prst="roundRect">
-            <a:avLst/>
-          </a:prstGeom>
-          <a:solidFill>
-            <a:srgbClr val="8E6F3E"/>
-          </a:solidFill>
-          <a:ln>
-            <a:noFill/>
-          </a:ln>
-        </p:spPr>
-        <p:txBody>
-          <a:bodyPr wrap="square" lIns="45720" tIns="0" rIns="45720" bIns="0" anchor="ctr"/>
-          <a:lstStyle/>
-          <a:p>
-            <a:pPr algn="ctr">
-              <a:buNone/>
-            </a:pPr>
-            <a:r>
-              <a:rPr lang="en-US" sz="1200" b="1" i="0" dirty="0">
-                <a:solidFill>
-                  <a:srgbClr val="FFFFFF"/>
-                </a:solidFill>
-              </a:rPr>
-              <a:t>THINK · PAIR · SHARE</a:t>
-            </a:r>
-          </a:p>
-        </p:txBody>
-      </p:sp>
-      <p:sp>
-        <p:nvSpPr>
-          <p:cNvPr id="300" name="Checklist"/>
-          <p:cNvSpPr/>
-          <p:nvPr/>
-        </p:nvSpPr>
-        <p:spPr>
-          <a:xfrm>
-            <a:off x="274320" y="3200000"/>
-            <a:ext cx="8595360" cy="1950000"/>
+            <a:off x="274320" y="980000"/>
+            <a:ext cx="8595360" cy="640000"/>
           </a:xfrm>
           <a:prstGeom prst="rect">
             <a:avLst/>
@@ -25957,124 +25358,298 @@
           </a:ln>
         </p:spPr>
         <p:txBody>
-          <a:bodyPr wrap="square" lIns="91440" tIns="45720" rIns="91440" bIns="45720" anchor="t"/>
+          <a:bodyPr wrap="square" lIns="182880" tIns="45720" rIns="91440" bIns="45720" anchor="ctr"/>
           <a:lstStyle/>
           <a:p>
             <a:pPr algn="l">
               <a:buNone/>
             </a:pPr>
             <a:r>
-              <a:rPr lang="en-US" sz="1500" b="1" i="0" dirty="0">
+              <a:rPr lang="en-US" sz="1600" b="1" i="0" dirty="0">
                 <a:solidFill>
                   <a:srgbClr val="8E6F3E"/>
                 </a:solidFill>
               </a:rPr>
-              <a:t>FIVE COMPOSITION CHECKS</a:t>
-            </a:r>
-          </a:p>
+              <a:t xml:space="preserve">1   </a:t>
+            </a:r>
+            <a:r>
+              <a:rPr lang="en-US" sz="1600" b="1" i="0" dirty="0">
+                <a:solidFill>
+                  <a:srgbClr val="5C4826"/>
+                </a:solidFill>
+              </a:rPr>
+              <a:t xml:space="preserve">Budgets compose </a:t>
+            </a:r>
+            <a:r>
+              <a:rPr lang="en-US" sz="1500" b="0" i="0" dirty="0">
+                <a:solidFill>
+                  <a:srgbClr val="555960"/>
+                </a:solidFill>
+              </a:rPr>
+              <a:t>— latency, memory, cost, error stay acceptable in aggregate</a:t>
+            </a:r>
+          </a:p>
+        </p:txBody>
+      </p:sp>
+      <p:sp>
+        <p:nvSpPr>
+          <p:cNvPr id="301" name="Check2"/>
+          <p:cNvSpPr/>
+          <p:nvPr/>
+        </p:nvSpPr>
+        <p:spPr>
+          <a:xfrm>
+            <a:off x="274320" y="1720000"/>
+            <a:ext cx="8595360" cy="640000"/>
+          </a:xfrm>
+          <a:prstGeom prst="rect">
+            <a:avLst/>
+          </a:prstGeom>
+          <a:solidFill>
+            <a:srgbClr val="F5F1E8"/>
+          </a:solidFill>
+          <a:ln w="12700">
+            <a:solidFill>
+              <a:srgbClr val="C9B991"/>
+            </a:solidFill>
+          </a:ln>
+        </p:spPr>
+        <p:txBody>
+          <a:bodyPr wrap="square" lIns="182880" tIns="45720" rIns="91440" bIns="45720" anchor="ctr"/>
+          <a:lstStyle/>
           <a:p>
             <a:pPr algn="l">
               <a:buNone/>
             </a:pPr>
             <a:r>
-              <a:rPr lang="en-US" sz="1400" b="1" i="0" dirty="0">
+              <a:rPr lang="en-US" sz="1600" b="1" i="0" dirty="0">
+                <a:solidFill>
+                  <a:srgbClr val="8E6F3E"/>
+                </a:solidFill>
+              </a:rPr>
+              <a:t xml:space="preserve">2   </a:t>
+            </a:r>
+            <a:r>
+              <a:rPr lang="en-US" sz="1600" b="1" i="0" dirty="0">
                 <a:solidFill>
                   <a:srgbClr val="5C4826"/>
                 </a:solidFill>
               </a:rPr>
-              <a:t xml:space="preserve">✓  Budgets compose </a:t>
-            </a:r>
-            <a:r>
-              <a:rPr lang="en-US" sz="1400" b="0" i="0" dirty="0">
+              <a:t xml:space="preserve">Responsibilities cover the obligation </a:t>
+            </a:r>
+            <a:r>
+              <a:rPr lang="en-US" sz="1500" b="0" i="0" dirty="0">
+                <a:solidFill>
+                  <a:srgbClr val="555960"/>
+                </a:solidFill>
+              </a:rPr>
+              <a:t>— assumptions leave no gaps between parts</a:t>
+            </a:r>
+          </a:p>
+        </p:txBody>
+      </p:sp>
+      <p:sp>
+        <p:nvSpPr>
+          <p:cNvPr id="302" name="Check3"/>
+          <p:cNvSpPr/>
+          <p:nvPr/>
+        </p:nvSpPr>
+        <p:spPr>
+          <a:xfrm>
+            <a:off x="274320" y="2460000"/>
+            <a:ext cx="8595360" cy="640000"/>
+          </a:xfrm>
+          <a:prstGeom prst="rect">
+            <a:avLst/>
+          </a:prstGeom>
+          <a:solidFill>
+            <a:srgbClr val="F5F1E8"/>
+          </a:solidFill>
+          <a:ln w="12700">
+            <a:solidFill>
+              <a:srgbClr val="C9B991"/>
+            </a:solidFill>
+          </a:ln>
+        </p:spPr>
+        <p:txBody>
+          <a:bodyPr wrap="square" lIns="182880" tIns="45720" rIns="91440" bIns="45720" anchor="ctr"/>
+          <a:lstStyle/>
+          <a:p>
+            <a:pPr algn="l">
+              <a:buNone/>
+            </a:pPr>
+            <a:r>
+              <a:rPr lang="en-US" sz="1600" b="1" i="0" dirty="0">
+                <a:solidFill>
+                  <a:srgbClr val="8E6F3E"/>
+                </a:solidFill>
+              </a:rPr>
+              <a:t xml:space="preserve">3   </a:t>
+            </a:r>
+            <a:r>
+              <a:rPr lang="en-US" sz="1600" b="1" i="0" dirty="0">
                 <a:solidFill>
                   <a:srgbClr val="5C4826"/>
                 </a:solidFill>
               </a:rPr>
-              <a:t>— latency, memory, cost, error stay acceptable in aggregate</a:t>
-            </a:r>
-          </a:p>
+              <a:t xml:space="preserve">Assumptions compose </a:t>
+            </a:r>
+            <a:r>
+              <a:rPr lang="en-US" sz="1500" b="0" i="0" dirty="0">
+                <a:solidFill>
+                  <a:srgbClr val="555960"/>
+                </a:solidFill>
+              </a:rPr>
+              <a:t>— what one part expects, another actually guarantees</a:t>
+            </a:r>
+          </a:p>
+        </p:txBody>
+      </p:sp>
+      <p:sp>
+        <p:nvSpPr>
+          <p:cNvPr id="303" name="Check4"/>
+          <p:cNvSpPr/>
+          <p:nvPr/>
+        </p:nvSpPr>
+        <p:spPr>
+          <a:xfrm>
+            <a:off x="274320" y="3200000"/>
+            <a:ext cx="8595360" cy="640000"/>
+          </a:xfrm>
+          <a:prstGeom prst="rect">
+            <a:avLst/>
+          </a:prstGeom>
+          <a:solidFill>
+            <a:srgbClr val="F5F1E8"/>
+          </a:solidFill>
+          <a:ln w="12700">
+            <a:solidFill>
+              <a:srgbClr val="C9B991"/>
+            </a:solidFill>
+          </a:ln>
+        </p:spPr>
+        <p:txBody>
+          <a:bodyPr wrap="square" lIns="182880" tIns="45720" rIns="91440" bIns="45720" anchor="ctr"/>
+          <a:lstStyle/>
           <a:p>
             <a:pPr algn="l">
               <a:buNone/>
             </a:pPr>
             <a:r>
-              <a:rPr lang="en-US" sz="1400" b="1" i="0" dirty="0">
+              <a:rPr lang="en-US" sz="1600" b="1" i="0" dirty="0">
+                <a:solidFill>
+                  <a:srgbClr val="8E6F3E"/>
+                </a:solidFill>
+              </a:rPr>
+              <a:t xml:space="preserve">4   </a:t>
+            </a:r>
+            <a:r>
+              <a:rPr lang="en-US" sz="1600" b="1" i="0" dirty="0">
                 <a:solidFill>
                   <a:srgbClr val="5C4826"/>
                 </a:solidFill>
               </a:rPr>
-              <a:t xml:space="preserve">✓  Responsibilities cover the obligation </a:t>
-            </a:r>
-            <a:r>
-              <a:rPr lang="en-US" sz="1400" b="0" i="0" dirty="0">
-                <a:solidFill>
-                  <a:srgbClr val="5C4826"/>
-                </a:solidFill>
-              </a:rPr>
-              <a:t>— assumptions leave no gaps between parts</a:t>
-            </a:r>
-          </a:p>
+              <a:t xml:space="preserve">Mechanisms interact safely </a:t>
+            </a:r>
+            <a:r>
+              <a:rPr lang="en-US" sz="1500" b="0" i="0" dirty="0">
+                <a:solidFill>
+                  <a:srgbClr val="555960"/>
+                </a:solidFill>
+              </a:rPr>
+              <a:t>— individually sound choices do not interfere</a:t>
+            </a:r>
+          </a:p>
+        </p:txBody>
+      </p:sp>
+      <p:sp>
+        <p:nvSpPr>
+          <p:cNvPr id="304" name="Check5"/>
+          <p:cNvSpPr/>
+          <p:nvPr/>
+        </p:nvSpPr>
+        <p:spPr>
+          <a:xfrm>
+            <a:off x="274320" y="3940000"/>
+            <a:ext cx="8595360" cy="640000"/>
+          </a:xfrm>
+          <a:prstGeom prst="rect">
+            <a:avLst/>
+          </a:prstGeom>
+          <a:solidFill>
+            <a:srgbClr val="8E6F3E"/>
+          </a:solidFill>
+          <a:ln>
+            <a:noFill/>
+          </a:ln>
+        </p:spPr>
+        <p:txBody>
+          <a:bodyPr wrap="square" lIns="182880" tIns="45720" rIns="91440" bIns="45720" anchor="ctr"/>
+          <a:lstStyle/>
           <a:p>
             <a:pPr algn="l">
               <a:buNone/>
             </a:pPr>
             <a:r>
-              <a:rPr lang="en-US" sz="1400" b="1" i="0" dirty="0">
-                <a:solidFill>
-                  <a:srgbClr val="5C4826"/>
-                </a:solidFill>
-              </a:rPr>
-              <a:t xml:space="preserve">✓  Assumptions compose </a:t>
-            </a:r>
-            <a:r>
-              <a:rPr lang="en-US" sz="1400" b="0" i="0" dirty="0">
-                <a:solidFill>
-                  <a:srgbClr val="5C4826"/>
-                </a:solidFill>
-              </a:rPr>
-              <a:t>— what one part expects, another actually guarantees</a:t>
-            </a:r>
-          </a:p>
-          <a:p>
-            <a:pPr algn="l">
-              <a:buNone/>
-            </a:pPr>
-            <a:r>
-              <a:rPr lang="en-US" sz="1400" b="1" i="0" dirty="0">
-                <a:solidFill>
-                  <a:srgbClr val="5C4826"/>
-                </a:solidFill>
-              </a:rPr>
-              <a:t xml:space="preserve">✓  Mechanisms interact safely </a:t>
-            </a:r>
-            <a:r>
-              <a:rPr lang="en-US" sz="1400" b="0" i="0" dirty="0">
-                <a:solidFill>
-                  <a:srgbClr val="5C4826"/>
-                </a:solidFill>
-              </a:rPr>
-              <a:t>— individually sound choices do not interfere</a:t>
-            </a:r>
-          </a:p>
-          <a:p>
-            <a:pPr algn="l">
-              <a:buNone/>
-            </a:pPr>
-            <a:r>
-              <a:rPr lang="en-US" sz="1400" b="1" i="0" dirty="0">
-                <a:solidFill>
-                  <a:srgbClr val="5C4826"/>
-                </a:solidFill>
-              </a:rPr>
-              <a:t xml:space="preserve">✓  Architectural properties remain true </a:t>
-            </a:r>
-            <a:r>
-              <a:rPr lang="en-US" sz="1400" b="0" i="0" dirty="0">
-                <a:solidFill>
-                  <a:srgbClr val="5C4826"/>
-                </a:solidFill>
-              </a:rPr>
-              <a:t>— isolation, dependency, security, reliability</a:t>
+              <a:rPr lang="en-US" sz="1600" b="1" i="0" dirty="0">
+                <a:solidFill>
+                  <a:srgbClr val="F0E6CE"/>
+                </a:solidFill>
+              </a:rPr>
+              <a:t xml:space="preserve">5   </a:t>
+            </a:r>
+            <a:r>
+              <a:rPr lang="en-US" sz="1600" b="1" i="0" dirty="0">
+                <a:solidFill>
+                  <a:srgbClr val="FFFFFF"/>
+                </a:solidFill>
+              </a:rPr>
+              <a:t xml:space="preserve">Architectural properties remain true </a:t>
+            </a:r>
+            <a:r>
+              <a:rPr lang="en-US" sz="1500" b="0" i="0" dirty="0">
+                <a:solidFill>
+                  <a:srgbClr val="FFFFFF"/>
+                </a:solidFill>
+              </a:rPr>
+              <a:t>— isolation · dependency · security · reliability</a:t>
+            </a:r>
+          </a:p>
+        </p:txBody>
+      </p:sp>
+      <p:sp>
+        <p:nvSpPr>
+          <p:cNvPr id="305" name="PunchLine"/>
+          <p:cNvSpPr txBox="1"/>
+          <p:nvPr/>
+        </p:nvSpPr>
+        <p:spPr>
+          <a:xfrm>
+            <a:off x="654320" y="4880000"/>
+            <a:ext cx="7835360" cy="800000"/>
+          </a:xfrm>
+          <a:prstGeom prst="rect">
+            <a:avLst/>
+          </a:prstGeom>
+          <a:noFill/>
+          <a:ln>
+            <a:noFill/>
+          </a:ln>
+        </p:spPr>
+        <p:txBody>
+          <a:bodyPr wrap="square" lIns="0" tIns="0" rIns="0" bIns="0" anchor="t"/>
+          <a:lstStyle/>
+          <a:p>
+            <a:pPr algn="ctr">
+              <a:buNone/>
+            </a:pPr>
+            <a:r>
+              <a:rPr lang="en-US" sz="1700" b="0" i="1" dirty="0">
+                <a:solidFill>
+                  <a:srgbClr val="000000"/>
+                </a:solidFill>
+              </a:rPr>
+              <a:t>A Design can satisfy its own local responsibility while quietly destroying a property that Architecture was intended to establish.</a:t>
             </a:r>
           </a:p>
         </p:txBody>
@@ -26144,7 +25719,7 @@
                             </p:stCondLst>
                             <p:childTnLst>
                               <p:par>
-                                <p:cTn id="5" presetID="10" presetClass="entr" presetSubtype="0" fill="hold" nodeType="clickEffect">
+                                <p:cTn id="5" presetID="10" presetClass="entr" presetSubtype="0" fill="hold" grpId="0" nodeType="clickEffect">
                                   <p:stCondLst>
                                     <p:cond delay="0"/>
                                   </p:stCondLst>
@@ -26184,6 +25759,271 @@
                       </p:childTnLst>
                     </p:cTn>
                   </p:par>
+                  <p:par>
+                    <p:cTn id="8" fill="hold">
+                      <p:stCondLst>
+                        <p:cond delay="indefinite"/>
+                      </p:stCondLst>
+                      <p:childTnLst>
+                        <p:par>
+                          <p:cTn id="9" fill="hold">
+                            <p:stCondLst>
+                              <p:cond delay="0"/>
+                            </p:stCondLst>
+                            <p:childTnLst>
+                              <p:par>
+                                <p:cTn id="10" presetID="10" presetClass="entr" presetSubtype="0" fill="hold" grpId="1" nodeType="clickEffect">
+                                  <p:stCondLst>
+                                    <p:cond delay="0"/>
+                                  </p:stCondLst>
+                                  <p:childTnLst>
+                                    <p:set>
+                                      <p:cBhvr>
+                                        <p:cTn id="11" dur="1" fill="hold">
+                                          <p:stCondLst>
+                                            <p:cond delay="0"/>
+                                          </p:stCondLst>
+                                        </p:cTn>
+                                        <p:tgtEl>
+                                          <p:spTgt spid="301"/>
+                                        </p:tgtEl>
+                                        <p:attrNameLst>
+                                          <p:attrName>style.visibility</p:attrName>
+                                        </p:attrNameLst>
+                                      </p:cBhvr>
+                                      <p:to>
+                                        <p:strVal val="visible"/>
+                                      </p:to>
+                                    </p:set>
+                                    <p:animEffect transition="in" filter="fade">
+                                      <p:cBhvr>
+                                        <p:cTn id="12" dur="500"/>
+                                        <p:tgtEl>
+                                          <p:spTgt spid="301"/>
+                                        </p:tgtEl>
+                                      </p:cBhvr>
+                                    </p:animEffect>
+                                  </p:childTnLst>
+                                </p:cTn>
+                              </p:par>
+                            </p:childTnLst>
+                          </p:cTn>
+                        </p:par>
+                      </p:childTnLst>
+                    </p:cTn>
+                  </p:par>
+                  <p:par>
+                    <p:cTn id="13" fill="hold">
+                      <p:stCondLst>
+                        <p:cond delay="indefinite"/>
+                      </p:stCondLst>
+                      <p:childTnLst>
+                        <p:par>
+                          <p:cTn id="14" fill="hold">
+                            <p:stCondLst>
+                              <p:cond delay="0"/>
+                            </p:stCondLst>
+                            <p:childTnLst>
+                              <p:par>
+                                <p:cTn id="15" presetID="10" presetClass="entr" presetSubtype="0" fill="hold" grpId="2" nodeType="clickEffect">
+                                  <p:stCondLst>
+                                    <p:cond delay="0"/>
+                                  </p:stCondLst>
+                                  <p:childTnLst>
+                                    <p:set>
+                                      <p:cBhvr>
+                                        <p:cTn id="16" dur="1" fill="hold">
+                                          <p:stCondLst>
+                                            <p:cond delay="0"/>
+                                          </p:stCondLst>
+                                        </p:cTn>
+                                        <p:tgtEl>
+                                          <p:spTgt spid="302"/>
+                                        </p:tgtEl>
+                                        <p:attrNameLst>
+                                          <p:attrName>style.visibility</p:attrName>
+                                        </p:attrNameLst>
+                                      </p:cBhvr>
+                                      <p:to>
+                                        <p:strVal val="visible"/>
+                                      </p:to>
+                                    </p:set>
+                                    <p:animEffect transition="in" filter="fade">
+                                      <p:cBhvr>
+                                        <p:cTn id="17" dur="500"/>
+                                        <p:tgtEl>
+                                          <p:spTgt spid="302"/>
+                                        </p:tgtEl>
+                                      </p:cBhvr>
+                                    </p:animEffect>
+                                  </p:childTnLst>
+                                </p:cTn>
+                              </p:par>
+                            </p:childTnLst>
+                          </p:cTn>
+                        </p:par>
+                      </p:childTnLst>
+                    </p:cTn>
+                  </p:par>
+                  <p:par>
+                    <p:cTn id="18" fill="hold">
+                      <p:stCondLst>
+                        <p:cond delay="indefinite"/>
+                      </p:stCondLst>
+                      <p:childTnLst>
+                        <p:par>
+                          <p:cTn id="19" fill="hold">
+                            <p:stCondLst>
+                              <p:cond delay="0"/>
+                            </p:stCondLst>
+                            <p:childTnLst>
+                              <p:par>
+                                <p:cTn id="20" presetID="10" presetClass="entr" presetSubtype="0" fill="hold" grpId="3" nodeType="clickEffect">
+                                  <p:stCondLst>
+                                    <p:cond delay="0"/>
+                                  </p:stCondLst>
+                                  <p:childTnLst>
+                                    <p:set>
+                                      <p:cBhvr>
+                                        <p:cTn id="21" dur="1" fill="hold">
+                                          <p:stCondLst>
+                                            <p:cond delay="0"/>
+                                          </p:stCondLst>
+                                        </p:cTn>
+                                        <p:tgtEl>
+                                          <p:spTgt spid="303"/>
+                                        </p:tgtEl>
+                                        <p:attrNameLst>
+                                          <p:attrName>style.visibility</p:attrName>
+                                        </p:attrNameLst>
+                                      </p:cBhvr>
+                                      <p:to>
+                                        <p:strVal val="visible"/>
+                                      </p:to>
+                                    </p:set>
+                                    <p:animEffect transition="in" filter="fade">
+                                      <p:cBhvr>
+                                        <p:cTn id="22" dur="500"/>
+                                        <p:tgtEl>
+                                          <p:spTgt spid="303"/>
+                                        </p:tgtEl>
+                                      </p:cBhvr>
+                                    </p:animEffect>
+                                  </p:childTnLst>
+                                </p:cTn>
+                              </p:par>
+                            </p:childTnLst>
+                          </p:cTn>
+                        </p:par>
+                      </p:childTnLst>
+                    </p:cTn>
+                  </p:par>
+                  <p:par>
+                    <p:cTn id="23" fill="hold">
+                      <p:stCondLst>
+                        <p:cond delay="indefinite"/>
+                      </p:stCondLst>
+                      <p:childTnLst>
+                        <p:par>
+                          <p:cTn id="24" fill="hold">
+                            <p:stCondLst>
+                              <p:cond delay="0"/>
+                            </p:stCondLst>
+                            <p:childTnLst>
+                              <p:par>
+                                <p:cTn id="25" presetID="10" presetClass="entr" presetSubtype="0" fill="hold" grpId="4" nodeType="clickEffect">
+                                  <p:stCondLst>
+                                    <p:cond delay="0"/>
+                                  </p:stCondLst>
+                                  <p:childTnLst>
+                                    <p:set>
+                                      <p:cBhvr>
+                                        <p:cTn id="26" dur="1" fill="hold">
+                                          <p:stCondLst>
+                                            <p:cond delay="0"/>
+                                          </p:stCondLst>
+                                        </p:cTn>
+                                        <p:tgtEl>
+                                          <p:spTgt spid="304"/>
+                                        </p:tgtEl>
+                                        <p:attrNameLst>
+                                          <p:attrName>style.visibility</p:attrName>
+                                        </p:attrNameLst>
+                                      </p:cBhvr>
+                                      <p:to>
+                                        <p:strVal val="visible"/>
+                                      </p:to>
+                                    </p:set>
+                                    <p:animEffect transition="in" filter="fade">
+                                      <p:cBhvr>
+                                        <p:cTn id="27" dur="500"/>
+                                        <p:tgtEl>
+                                          <p:spTgt spid="304"/>
+                                        </p:tgtEl>
+                                      </p:cBhvr>
+                                    </p:animEffect>
+                                  </p:childTnLst>
+                                </p:cTn>
+                              </p:par>
+                            </p:childTnLst>
+                          </p:cTn>
+                        </p:par>
+                      </p:childTnLst>
+                    </p:cTn>
+                  </p:par>
+                  <p:par>
+                    <p:cTn id="28" fill="hold">
+                      <p:stCondLst>
+                        <p:cond delay="indefinite"/>
+                      </p:stCondLst>
+                      <p:childTnLst>
+                        <p:par>
+                          <p:cTn id="29" fill="hold">
+                            <p:stCondLst>
+                              <p:cond delay="0"/>
+                            </p:stCondLst>
+                            <p:childTnLst>
+                              <p:par>
+                                <p:cTn id="30" presetID="10" presetClass="entr" presetSubtype="0" fill="hold" grpId="5" nodeType="clickEffect">
+                                  <p:stCondLst>
+                                    <p:cond delay="0"/>
+                                  </p:stCondLst>
+                                  <p:childTnLst>
+                                    <p:set>
+                                      <p:cBhvr>
+                                        <p:cTn id="31" dur="1" fill="hold">
+                                          <p:stCondLst>
+                                            <p:cond delay="0"/>
+                                          </p:stCondLst>
+                                        </p:cTn>
+                                        <p:tgtEl>
+                                          <p:spTgt spid="305"/>
+                                        </p:tgtEl>
+                                        <p:attrNameLst>
+                                          <p:attrName>style.visibility</p:attrName>
+                                        </p:attrNameLst>
+                                      </p:cBhvr>
+                                      <p:to>
+                                        <p:strVal val="visible"/>
+                                      </p:to>
+                                    </p:set>
+                                    <p:animEffect transition="in" filter="fade">
+                                      <p:cBhvr>
+                                        <p:cTn id="32" dur="500"/>
+                                        <p:tgtEl>
+                                          <p:spTgt spid="305"/>
+                                        </p:tgtEl>
+                                      </p:cBhvr>
+                                    </p:animEffect>
+                                  </p:childTnLst>
+                                </p:cTn>
+                              </p:par>
+                            </p:childTnLst>
+                          </p:cTn>
+                        </p:par>
+                      </p:childTnLst>
+                    </p:cTn>
+                  </p:par>
                 </p:childTnLst>
               </p:cTn>
               <p:prevCondLst>
@@ -26205,6 +26045,14 @@
         </p:cTn>
       </p:par>
     </p:tnLst>
+    <p:bldLst>
+      <p:bldP spid="300" grpId="0"/>
+      <p:bldP spid="301" grpId="1"/>
+      <p:bldP spid="302" grpId="2"/>
+      <p:bldP spid="303" grpId="3"/>
+      <p:bldP spid="304" grpId="4"/>
+      <p:bldP spid="305" grpId="5"/>
+    </p:bldLst>
   </p:timing>
 </p:sld>
 </file>
@@ -26481,12 +26329,12 @@
               <a:buNone/>
             </a:pPr>
             <a:r>
-              <a:rPr lang="en-US" sz="2100" b="0" i="1" dirty="0">
+              <a:rPr lang="en-US" sz="1300" b="0" i="1" dirty="0">
                 <a:solidFill>
                   <a:srgbClr val="FFFFFF"/>
                 </a:solidFill>
               </a:rPr>
-              <a:t>strategy</a:t>
+              <a:t>responsibility · boundaries · interfaces · interaction rules</a:t>
             </a:r>
           </a:p>
         </p:txBody>
@@ -26793,20 +26641,38 @@
           </a:p>
         </p:txBody>
       </p:sp>
-      <p:cxnSp>
-        <p:nvCxnSpPr>
+      <p:sp>
+        <p:nvSpPr>
           <p:cNvPr id="110" name="L110"/>
-          <p:cNvCxnSpPr/>
-          <p:nvPr/>
-        </p:nvCxnSpPr>
+          <p:cNvSpPr/>
+          <p:nvPr/>
+        </p:nvSpPr>
         <p:spPr>
           <a:xfrm>
             <a:off x="1761999" y="4668367"/>
-            <a:ext cx="2810000" cy="330200"/>
-          </a:xfrm>
-          <a:prstGeom prst="straightConnector1">
-            <a:avLst/>
-          </a:prstGeom>
+            <a:ext cx="1110001" cy="736600"/>
+          </a:xfrm>
+          <a:custGeom>
+            <a:avLst/>
+            <a:gdLst/>
+            <a:ahLst/>
+            <a:cxnLst/>
+            <a:rect l="l" t="t" r="r" b="b"/>
+            <a:pathLst>
+              <a:path w="1110001" h="736600" fill="none">
+                <a:moveTo>
+                  <a:pt x="0" y="0"/>
+                </a:moveTo>
+                <a:lnTo>
+                  <a:pt x="0" y="736600"/>
+                </a:lnTo>
+                <a:lnTo>
+                  <a:pt x="1110001" y="736600"/>
+                </a:lnTo>
+              </a:path>
+            </a:pathLst>
+          </a:custGeom>
+          <a:noFill/>
           <a:ln w="38100">
             <a:solidFill>
               <a:srgbClr val="8E6F3E"/>
@@ -26814,7 +26680,7 @@
             <a:tailEnd type="triangle" w="med" len="med"/>
           </a:ln>
         </p:spPr>
-      </p:cxnSp>
+      </p:sp>
       <p:cxnSp>
         <p:nvCxnSpPr>
           <p:cNvPr id="111" name="L111"/>
@@ -26837,20 +26703,38 @@
           </a:ln>
         </p:spPr>
       </p:cxnSp>
-      <p:cxnSp>
-        <p:nvCxnSpPr>
+      <p:sp>
+        <p:nvSpPr>
           <p:cNvPr id="112" name="L112"/>
-          <p:cNvCxnSpPr/>
-          <p:nvPr/>
-        </p:nvCxnSpPr>
-        <p:spPr>
-          <a:xfrm flipH="1">
-            <a:off x="4572000" y="4668367"/>
-            <a:ext cx="2810000" cy="330200"/>
-          </a:xfrm>
-          <a:prstGeom prst="straightConnector1">
-            <a:avLst/>
-          </a:prstGeom>
+          <p:cNvSpPr/>
+          <p:nvPr/>
+        </p:nvSpPr>
+        <p:spPr>
+          <a:xfrm>
+            <a:off x="6272000" y="4668367"/>
+            <a:ext cx="1110000" cy="736600"/>
+          </a:xfrm>
+          <a:custGeom>
+            <a:avLst/>
+            <a:gdLst/>
+            <a:ahLst/>
+            <a:cxnLst/>
+            <a:rect l="l" t="t" r="r" b="b"/>
+            <a:pathLst>
+              <a:path w="1110000" h="736600" fill="none">
+                <a:moveTo>
+                  <a:pt x="1110000" y="0"/>
+                </a:moveTo>
+                <a:lnTo>
+                  <a:pt x="1110000" y="736600"/>
+                </a:lnTo>
+                <a:lnTo>
+                  <a:pt x="0" y="736600"/>
+                </a:lnTo>
+              </a:path>
+            </a:pathLst>
+          </a:custGeom>
+          <a:noFill/>
           <a:ln w="38100">
             <a:solidFill>
               <a:srgbClr val="8E6F3E"/>
@@ -26858,7 +26742,7 @@
             <a:tailEnd type="triangle" w="med" len="med"/>
           </a:ln>
         </p:spPr>
-      </p:cxnSp>
+      </p:sp>
       <p:sp>
         <p:nvSpPr>
           <p:cNvPr id="113" name="FooterBand"/>
@@ -28993,7 +28877,7 @@
                   <a:srgbClr val="000000"/>
                 </a:solidFill>
               </a:rPr>
-              <a:t>Architecture can recur during Design</a:t>
+              <a:t>Architecture and Design recur as freedom narrows</a:t>
             </a:r>
           </a:p>
         </p:txBody>
@@ -29023,18 +28907,39 @@
       </p:sp>
       <p:sp>
         <p:nvSpPr>
-          <p:cNvPr id="100" name="S100"/>
+          <p:cNvPr id="100" name="FunnelSpec"/>
           <p:cNvSpPr/>
           <p:nvPr/>
         </p:nvSpPr>
         <p:spPr>
           <a:xfrm>
-            <a:off x="1888000" y="1076964"/>
-            <a:ext cx="5368000" cy="1300000"/>
-          </a:xfrm>
-          <a:prstGeom prst="rect">
-            <a:avLst/>
-          </a:prstGeom>
+            <a:off x="622000" y="980000"/>
+            <a:ext cx="7900000" cy="880000"/>
+          </a:xfrm>
+          <a:custGeom>
+            <a:avLst/>
+            <a:gdLst/>
+            <a:ahLst/>
+            <a:cxnLst/>
+            <a:rect l="l" t="t" r="r" b="b"/>
+            <a:pathLst>
+              <a:path w="7900000" h="880000">
+                <a:moveTo>
+                  <a:pt x="0" y="0"/>
+                </a:moveTo>
+                <a:lnTo>
+                  <a:pt x="7900000" y="0"/>
+                </a:lnTo>
+                <a:lnTo>
+                  <a:pt x="7300000" y="880000"/>
+                </a:lnTo>
+                <a:lnTo>
+                  <a:pt x="600000" y="880000"/>
+                </a:lnTo>
+                <a:close/>
+              </a:path>
+            </a:pathLst>
+          </a:custGeom>
           <a:solidFill>
             <a:srgbClr val="8E6F3E"/>
           </a:solidFill>
@@ -29050,90 +28955,65 @@
               <a:buNone/>
             </a:pPr>
             <a:r>
-              <a:rPr lang="en-US" sz="3000" b="1" i="0" dirty="0">
+              <a:rPr lang="en-US" sz="1700" b="1" i="0" dirty="0">
                 <a:solidFill>
                   <a:srgbClr val="FFFFFF"/>
                 </a:solidFill>
               </a:rPr>
-              <a:t>ARCHITECTURE</a:t>
-            </a:r>
-          </a:p>
-          <a:p>
-            <a:pPr algn="ctr">
-              <a:spcBef>
-                <a:spcPts val="100"/>
-              </a:spcBef>
-              <a:buNone/>
-            </a:pPr>
-            <a:r>
-              <a:rPr lang="en-US" sz="2000" b="0" i="1" dirty="0">
+              <a:t>SPECIFICATION</a:t>
+            </a:r>
+            <a:r>
+              <a:rPr lang="en-US" sz="1700" b="0" i="1" dirty="0">
                 <a:solidFill>
                   <a:srgbClr val="FFFFFF"/>
                 </a:solidFill>
               </a:rPr>
-              <a:t>strategy</a:t>
-            </a:r>
-          </a:p>
-          <a:p>
-            <a:pPr algn="ctr">
-              <a:spcBef>
-                <a:spcPts val="100"/>
-              </a:spcBef>
-              <a:buNone/>
-            </a:pPr>
-            <a:r>
-              <a:rPr lang="en-US" sz="2000" b="0" i="0" dirty="0">
-                <a:solidFill>
-                  <a:srgbClr val="FFFFFF"/>
-                </a:solidFill>
-              </a:rPr>
-              <a:t>affordances · constraints</a:t>
-            </a:r>
-          </a:p>
-        </p:txBody>
-      </p:sp>
-      <p:cxnSp>
-        <p:nvCxnSpPr>
-          <p:cNvPr id="101" name="L101"/>
-          <p:cNvCxnSpPr/>
-          <p:nvPr/>
-        </p:nvCxnSpPr>
-        <p:spPr>
-          <a:xfrm>
-            <a:off x="4572000" y="2441964"/>
-            <a:ext cx="0" cy="493999"/>
-          </a:xfrm>
-          <a:prstGeom prst="straightConnector1">
-            <a:avLst/>
-          </a:prstGeom>
-          <a:ln w="38100">
-            <a:solidFill>
-              <a:srgbClr val="8E6F3E"/>
-            </a:solidFill>
-            <a:tailEnd type="triangle" w="med" len="med"/>
-          </a:ln>
-        </p:spPr>
-      </p:cxnSp>
-      <p:sp>
-        <p:nvSpPr>
-          <p:cNvPr id="102" name="S102"/>
+              <a:t xml:space="preserve"> — acceptable realization space</a:t>
+            </a:r>
+          </a:p>
+        </p:txBody>
+      </p:sp>
+      <p:sp>
+        <p:nvSpPr>
+          <p:cNvPr id="101" name="FunnelArch"/>
           <p:cNvSpPr/>
           <p:nvPr/>
         </p:nvSpPr>
         <p:spPr>
           <a:xfrm>
-            <a:off x="1888000" y="3039964"/>
-            <a:ext cx="5368000" cy="1300000"/>
-          </a:xfrm>
-          <a:prstGeom prst="rect">
-            <a:avLst/>
-          </a:prstGeom>
+            <a:off x="1222000" y="1860000"/>
+            <a:ext cx="6700000" cy="880000"/>
+          </a:xfrm>
+          <a:custGeom>
+            <a:avLst/>
+            <a:gdLst/>
+            <a:ahLst/>
+            <a:cxnLst/>
+            <a:rect l="l" t="t" r="r" b="b"/>
+            <a:pathLst>
+              <a:path w="6700000" h="880000">
+                <a:moveTo>
+                  <a:pt x="0" y="0"/>
+                </a:moveTo>
+                <a:lnTo>
+                  <a:pt x="6700000" y="0"/>
+                </a:lnTo>
+                <a:lnTo>
+                  <a:pt x="6100000" y="880000"/>
+                </a:lnTo>
+                <a:lnTo>
+                  <a:pt x="600000" y="880000"/>
+                </a:lnTo>
+                <a:close/>
+              </a:path>
+            </a:pathLst>
+          </a:custGeom>
           <a:solidFill>
             <a:srgbClr val="F5F1E8"/>
           </a:solidFill>
-          <a:ln w="19050">
+          <a:ln w="12700">
             <a:solidFill>
-              <a:srgbClr val="5C4826"/>
+              <a:srgbClr val="C9B991"/>
             </a:solidFill>
           </a:ln>
         </p:spPr>
@@ -29145,62 +29025,59 @@
               <a:buNone/>
             </a:pPr>
             <a:r>
-              <a:rPr lang="en-US" sz="3000" b="1" i="0" dirty="0">
+              <a:rPr lang="en-US" sz="1700" b="1" i="0" dirty="0">
                 <a:solidFill>
                   <a:srgbClr val="5C4826"/>
                 </a:solidFill>
               </a:rPr>
-              <a:t>DESIGN</a:t>
-            </a:r>
-          </a:p>
-          <a:p>
-            <a:pPr algn="ctr">
-              <a:spcBef>
-                <a:spcPts val="100"/>
-              </a:spcBef>
-              <a:buNone/>
-            </a:pPr>
-            <a:r>
-              <a:rPr lang="en-US" sz="2000" b="0" i="1" dirty="0">
-                <a:solidFill>
-                  <a:srgbClr val="5C4826"/>
-                </a:solidFill>
-              </a:rPr>
-              <a:t>tactics</a:t>
-            </a:r>
-          </a:p>
-          <a:p>
-            <a:pPr algn="ctr">
-              <a:spcBef>
-                <a:spcPts val="100"/>
-              </a:spcBef>
-              <a:buNone/>
-            </a:pPr>
-            <a:r>
-              <a:rPr lang="en-US" sz="2000" b="0" i="0" dirty="0">
+              <a:t>ARCHITECTURE</a:t>
+            </a:r>
+            <a:r>
+              <a:rPr lang="en-US" sz="1700" b="0" i="1" dirty="0">
                 <a:solidFill>
                   <a:srgbClr val="000000"/>
                 </a:solidFill>
               </a:rPr>
-              <a:t>mechanisms · internal choices</a:t>
-            </a:r>
-          </a:p>
-        </p:txBody>
-      </p:sp>
-      <p:sp>
-        <p:nvSpPr>
-          <p:cNvPr id="103" name="S103"/>
+              <a:t xml:space="preserve"> — organization</a:t>
+            </a:r>
+          </a:p>
+        </p:txBody>
+      </p:sp>
+      <p:sp>
+        <p:nvSpPr>
+          <p:cNvPr id="102" name="FunnelArchDesign"/>
           <p:cNvSpPr/>
           <p:nvPr/>
         </p:nvSpPr>
         <p:spPr>
           <a:xfrm>
-            <a:off x="2122000" y="4781964"/>
-            <a:ext cx="4900000" cy="880000"/>
-          </a:xfrm>
-          <a:prstGeom prst="rect">
-            <a:avLst/>
-          </a:prstGeom>
+            <a:off x="1822000" y="2740000"/>
+            <a:ext cx="5500000" cy="880000"/>
+          </a:xfrm>
+          <a:custGeom>
+            <a:avLst/>
+            <a:gdLst/>
+            <a:ahLst/>
+            <a:cxnLst/>
+            <a:rect l="l" t="t" r="r" b="b"/>
+            <a:pathLst>
+              <a:path w="5500000" h="880000">
+                <a:moveTo>
+                  <a:pt x="0" y="0"/>
+                </a:moveTo>
+                <a:lnTo>
+                  <a:pt x="5500000" y="0"/>
+                </a:lnTo>
+                <a:lnTo>
+                  <a:pt x="4900000" y="880000"/>
+                </a:lnTo>
+                <a:lnTo>
+                  <a:pt x="600000" y="880000"/>
+                </a:lnTo>
+                <a:close/>
+              </a:path>
+            </a:pathLst>
+          </a:custGeom>
           <a:solidFill>
             <a:srgbClr val="FBF8F2"/>
           </a:solidFill>
@@ -29219,42 +29096,165 @@
               <a:buNone/>
             </a:pPr>
             <a:r>
-              <a:rPr lang="en-US" sz="2200" b="1" i="0" dirty="0">
+              <a:rPr lang="en-US" sz="1700" b="1" i="0" dirty="0">
                 <a:solidFill>
                   <a:srgbClr val="5C4826"/>
                 </a:solidFill>
               </a:rPr>
-              <a:t>SUBSYSTEM</a:t>
-            </a:r>
-          </a:p>
+              <a:t>ARCH / DESIGN</a:t>
+            </a:r>
+            <a:r>
+              <a:rPr lang="en-US" sz="1700" b="0" i="1" dirty="0">
+                <a:solidFill>
+                  <a:srgbClr val="555960"/>
+                </a:solidFill>
+              </a:rPr>
+              <a:t xml:space="preserve"> — organization? · mechanisms?</a:t>
+            </a:r>
+          </a:p>
+        </p:txBody>
+      </p:sp>
+      <p:sp>
+        <p:nvSpPr>
+          <p:cNvPr id="103" name="FunnelDesign"/>
+          <p:cNvSpPr/>
+          <p:nvPr/>
+        </p:nvSpPr>
+        <p:spPr>
+          <a:xfrm>
+            <a:off x="2422000" y="3620000"/>
+            <a:ext cx="4300000" cy="880000"/>
+          </a:xfrm>
+          <a:custGeom>
+            <a:avLst/>
+            <a:gdLst/>
+            <a:ahLst/>
+            <a:cxnLst/>
+            <a:rect l="l" t="t" r="r" b="b"/>
+            <a:pathLst>
+              <a:path w="4300000" h="880000">
+                <a:moveTo>
+                  <a:pt x="0" y="0"/>
+                </a:moveTo>
+                <a:lnTo>
+                  <a:pt x="4300000" y="0"/>
+                </a:lnTo>
+                <a:lnTo>
+                  <a:pt x="3700000" y="880000"/>
+                </a:lnTo>
+                <a:lnTo>
+                  <a:pt x="600000" y="880000"/>
+                </a:lnTo>
+                <a:close/>
+              </a:path>
+            </a:pathLst>
+          </a:custGeom>
+          <a:solidFill>
+            <a:srgbClr val="F5F1E8"/>
+          </a:solidFill>
+          <a:ln w="12700">
+            <a:solidFill>
+              <a:srgbClr val="C9B991"/>
+            </a:solidFill>
+          </a:ln>
+        </p:spPr>
+        <p:txBody>
+          <a:bodyPr wrap="square" lIns="91440" tIns="45720" rIns="91440" bIns="45720" anchor="ctr"/>
+          <a:lstStyle/>
           <a:p>
             <a:pPr algn="ctr">
-              <a:spcBef>
-                <a:spcPts val="80"/>
-              </a:spcBef>
-              <a:buNone/>
-            </a:pPr>
-            <a:r>
-              <a:rPr lang="en-US" sz="1800" b="0" i="1" dirty="0">
-                <a:solidFill>
-                  <a:srgbClr val="555960"/>
-                </a:solidFill>
-              </a:rPr>
-              <a:t>an architecture problem, one scope down</a:t>
-            </a:r>
-          </a:p>
-        </p:txBody>
-      </p:sp>
-      <p:sp>
-        <p:nvSpPr>
-          <p:cNvPr id="104" name="FooterItalic"/>
+              <a:buNone/>
+            </a:pPr>
+            <a:r>
+              <a:rPr lang="en-US" sz="1700" b="1" i="0" dirty="0">
+                <a:solidFill>
+                  <a:srgbClr val="5C4826"/>
+                </a:solidFill>
+              </a:rPr>
+              <a:t>DESIGN</a:t>
+            </a:r>
+            <a:r>
+              <a:rPr lang="en-US" sz="1700" b="0" i="1" dirty="0">
+                <a:solidFill>
+                  <a:srgbClr val="000000"/>
+                </a:solidFill>
+              </a:rPr>
+              <a:t xml:space="preserve"> — local mechanisms</a:t>
+            </a:r>
+          </a:p>
+        </p:txBody>
+      </p:sp>
+      <p:cxnSp>
+        <p:nvCxnSpPr>
+          <p:cNvPr id="104" name="FunnelArrow"/>
+          <p:cNvCxnSpPr/>
+          <p:nvPr/>
+        </p:nvCxnSpPr>
+        <p:spPr>
+          <a:xfrm>
+            <a:off x="4572000" y="4580000"/>
+            <a:ext cx="0" cy="370000"/>
+          </a:xfrm>
+          <a:prstGeom prst="straightConnector1">
+            <a:avLst/>
+          </a:prstGeom>
+          <a:ln w="38100">
+            <a:solidFill>
+              <a:srgbClr val="8E6F3E"/>
+            </a:solidFill>
+            <a:tailEnd type="triangle" w="med" len="med"/>
+          </a:ln>
+        </p:spPr>
+      </p:cxnSp>
+      <p:sp>
+        <p:nvSpPr>
+          <p:cNvPr id="105" name="FunnelImpl"/>
+          <p:cNvSpPr/>
+          <p:nvPr/>
+        </p:nvSpPr>
+        <p:spPr>
+          <a:xfrm>
+            <a:off x="3072000" y="5030000"/>
+            <a:ext cx="3000000" cy="560000"/>
+          </a:xfrm>
+          <a:prstGeom prst="rect">
+            <a:avLst/>
+          </a:prstGeom>
+          <a:solidFill>
+            <a:srgbClr val="8E6F3E"/>
+          </a:solidFill>
+          <a:ln>
+            <a:noFill/>
+          </a:ln>
+        </p:spPr>
+        <p:txBody>
+          <a:bodyPr wrap="square" lIns="91440" tIns="45720" rIns="91440" bIns="45720" anchor="ctr"/>
+          <a:lstStyle/>
+          <a:p>
+            <a:pPr algn="ctr">
+              <a:buNone/>
+            </a:pPr>
+            <a:r>
+              <a:rPr lang="en-US" sz="1800" b="1" i="0" dirty="0">
+                <a:solidFill>
+                  <a:srgbClr val="FFFFFF"/>
+                </a:solidFill>
+              </a:rPr>
+              <a:t>IMPLEMENTATION</a:t>
+            </a:r>
+          </a:p>
+        </p:txBody>
+      </p:sp>
+      <p:sp>
+        <p:nvSpPr>
+          <p:cNvPr id="106" name="FooterItalic"/>
           <p:cNvSpPr txBox="1"/>
           <p:nvPr/>
         </p:nvSpPr>
         <p:spPr>
           <a:xfrm>
-            <a:off x="274320" y="5852160"/>
-            <a:ext cx="8595360" cy="566928"/>
+            <a:off x="1144320" y="5860000"/>
+            <a:ext cx="6855360" cy="700000"/>
           </a:xfrm>
           <a:prstGeom prst="rect">
             <a:avLst/>
@@ -29272,12 +29272,12 @@
               <a:buNone/>
             </a:pPr>
             <a:r>
-              <a:rPr lang="en-US" sz="2000" b="0" i="1" dirty="0">
+              <a:rPr lang="en-US" sz="1700" b="0" i="1" dirty="0">
                 <a:solidFill>
                   <a:srgbClr val="000000"/>
                 </a:solidFill>
               </a:rPr>
-              <a:t>The distinction is relative to the scope we are engineering.</a:t>
+              <a:t>Each level removes degrees of freedom; opening a part may expose another Architecture / Design boundary.</a:t>
             </a:r>
           </a:p>
         </p:txBody>
@@ -29287,6 +29287,398 @@
   <p:clrMapOvr>
     <a:masterClrMapping/>
   </p:clrMapOvr>
+  <p:timing>
+    <p:tnLst>
+      <p:par>
+        <p:cTn id="1" dur="indefinite" restart="never" nodeType="tmRoot">
+          <p:childTnLst>
+            <p:seq concurrent="1" nextAc="seek">
+              <p:cTn id="2" dur="indefinite" nodeType="mainSeq">
+                <p:childTnLst>
+                  <p:par>
+                    <p:cTn id="3" fill="hold">
+                      <p:stCondLst>
+                        <p:cond delay="indefinite"/>
+                      </p:stCondLst>
+                      <p:childTnLst>
+                        <p:par>
+                          <p:cTn id="4" fill="hold">
+                            <p:stCondLst>
+                              <p:cond delay="0"/>
+                            </p:stCondLst>
+                            <p:childTnLst>
+                              <p:par>
+                                <p:cTn id="5" presetID="10" presetClass="entr" presetSubtype="0" fill="hold" grpId="0" nodeType="clickEffect">
+                                  <p:stCondLst>
+                                    <p:cond delay="0"/>
+                                  </p:stCondLst>
+                                  <p:childTnLst>
+                                    <p:set>
+                                      <p:cBhvr>
+                                        <p:cTn id="6" dur="1" fill="hold">
+                                          <p:stCondLst>
+                                            <p:cond delay="0"/>
+                                          </p:stCondLst>
+                                        </p:cTn>
+                                        <p:tgtEl>
+                                          <p:spTgt spid="100"/>
+                                        </p:tgtEl>
+                                        <p:attrNameLst>
+                                          <p:attrName>style.visibility</p:attrName>
+                                        </p:attrNameLst>
+                                      </p:cBhvr>
+                                      <p:to>
+                                        <p:strVal val="visible"/>
+                                      </p:to>
+                                    </p:set>
+                                    <p:animEffect transition="in" filter="fade">
+                                      <p:cBhvr>
+                                        <p:cTn id="7" dur="500"/>
+                                        <p:tgtEl>
+                                          <p:spTgt spid="100"/>
+                                        </p:tgtEl>
+                                      </p:cBhvr>
+                                    </p:animEffect>
+                                  </p:childTnLst>
+                                </p:cTn>
+                              </p:par>
+                            </p:childTnLst>
+                          </p:cTn>
+                        </p:par>
+                      </p:childTnLst>
+                    </p:cTn>
+                  </p:par>
+                  <p:par>
+                    <p:cTn id="8" fill="hold">
+                      <p:stCondLst>
+                        <p:cond delay="indefinite"/>
+                      </p:stCondLst>
+                      <p:childTnLst>
+                        <p:par>
+                          <p:cTn id="9" fill="hold">
+                            <p:stCondLst>
+                              <p:cond delay="0"/>
+                            </p:stCondLst>
+                            <p:childTnLst>
+                              <p:par>
+                                <p:cTn id="10" presetID="10" presetClass="entr" presetSubtype="0" fill="hold" grpId="1" nodeType="clickEffect">
+                                  <p:stCondLst>
+                                    <p:cond delay="0"/>
+                                  </p:stCondLst>
+                                  <p:childTnLst>
+                                    <p:set>
+                                      <p:cBhvr>
+                                        <p:cTn id="11" dur="1" fill="hold">
+                                          <p:stCondLst>
+                                            <p:cond delay="0"/>
+                                          </p:stCondLst>
+                                        </p:cTn>
+                                        <p:tgtEl>
+                                          <p:spTgt spid="101"/>
+                                        </p:tgtEl>
+                                        <p:attrNameLst>
+                                          <p:attrName>style.visibility</p:attrName>
+                                        </p:attrNameLst>
+                                      </p:cBhvr>
+                                      <p:to>
+                                        <p:strVal val="visible"/>
+                                      </p:to>
+                                    </p:set>
+                                    <p:animEffect transition="in" filter="fade">
+                                      <p:cBhvr>
+                                        <p:cTn id="12" dur="500"/>
+                                        <p:tgtEl>
+                                          <p:spTgt spid="101"/>
+                                        </p:tgtEl>
+                                      </p:cBhvr>
+                                    </p:animEffect>
+                                  </p:childTnLst>
+                                </p:cTn>
+                              </p:par>
+                            </p:childTnLst>
+                          </p:cTn>
+                        </p:par>
+                      </p:childTnLst>
+                    </p:cTn>
+                  </p:par>
+                  <p:par>
+                    <p:cTn id="13" fill="hold">
+                      <p:stCondLst>
+                        <p:cond delay="indefinite"/>
+                      </p:stCondLst>
+                      <p:childTnLst>
+                        <p:par>
+                          <p:cTn id="14" fill="hold">
+                            <p:stCondLst>
+                              <p:cond delay="0"/>
+                            </p:stCondLst>
+                            <p:childTnLst>
+                              <p:par>
+                                <p:cTn id="15" presetID="10" presetClass="entr" presetSubtype="0" fill="hold" grpId="2" nodeType="clickEffect">
+                                  <p:stCondLst>
+                                    <p:cond delay="0"/>
+                                  </p:stCondLst>
+                                  <p:childTnLst>
+                                    <p:set>
+                                      <p:cBhvr>
+                                        <p:cTn id="16" dur="1" fill="hold">
+                                          <p:stCondLst>
+                                            <p:cond delay="0"/>
+                                          </p:stCondLst>
+                                        </p:cTn>
+                                        <p:tgtEl>
+                                          <p:spTgt spid="102"/>
+                                        </p:tgtEl>
+                                        <p:attrNameLst>
+                                          <p:attrName>style.visibility</p:attrName>
+                                        </p:attrNameLst>
+                                      </p:cBhvr>
+                                      <p:to>
+                                        <p:strVal val="visible"/>
+                                      </p:to>
+                                    </p:set>
+                                    <p:animEffect transition="in" filter="fade">
+                                      <p:cBhvr>
+                                        <p:cTn id="17" dur="500"/>
+                                        <p:tgtEl>
+                                          <p:spTgt spid="102"/>
+                                        </p:tgtEl>
+                                      </p:cBhvr>
+                                    </p:animEffect>
+                                  </p:childTnLst>
+                                </p:cTn>
+                              </p:par>
+                            </p:childTnLst>
+                          </p:cTn>
+                        </p:par>
+                      </p:childTnLst>
+                    </p:cTn>
+                  </p:par>
+                  <p:par>
+                    <p:cTn id="18" fill="hold">
+                      <p:stCondLst>
+                        <p:cond delay="indefinite"/>
+                      </p:stCondLst>
+                      <p:childTnLst>
+                        <p:par>
+                          <p:cTn id="19" fill="hold">
+                            <p:stCondLst>
+                              <p:cond delay="0"/>
+                            </p:stCondLst>
+                            <p:childTnLst>
+                              <p:par>
+                                <p:cTn id="20" presetID="10" presetClass="entr" presetSubtype="0" fill="hold" grpId="3" nodeType="clickEffect">
+                                  <p:stCondLst>
+                                    <p:cond delay="0"/>
+                                  </p:stCondLst>
+                                  <p:childTnLst>
+                                    <p:set>
+                                      <p:cBhvr>
+                                        <p:cTn id="21" dur="1" fill="hold">
+                                          <p:stCondLst>
+                                            <p:cond delay="0"/>
+                                          </p:stCondLst>
+                                        </p:cTn>
+                                        <p:tgtEl>
+                                          <p:spTgt spid="103"/>
+                                        </p:tgtEl>
+                                        <p:attrNameLst>
+                                          <p:attrName>style.visibility</p:attrName>
+                                        </p:attrNameLst>
+                                      </p:cBhvr>
+                                      <p:to>
+                                        <p:strVal val="visible"/>
+                                      </p:to>
+                                    </p:set>
+                                    <p:animEffect transition="in" filter="fade">
+                                      <p:cBhvr>
+                                        <p:cTn id="22" dur="500"/>
+                                        <p:tgtEl>
+                                          <p:spTgt spid="103"/>
+                                        </p:tgtEl>
+                                      </p:cBhvr>
+                                    </p:animEffect>
+                                  </p:childTnLst>
+                                </p:cTn>
+                              </p:par>
+                            </p:childTnLst>
+                          </p:cTn>
+                        </p:par>
+                      </p:childTnLst>
+                    </p:cTn>
+                  </p:par>
+                  <p:par>
+                    <p:cTn id="23" fill="hold">
+                      <p:stCondLst>
+                        <p:cond delay="indefinite"/>
+                      </p:stCondLst>
+                      <p:childTnLst>
+                        <p:par>
+                          <p:cTn id="24" fill="hold">
+                            <p:stCondLst>
+                              <p:cond delay="0"/>
+                            </p:stCondLst>
+                            <p:childTnLst>
+                              <p:par>
+                                <p:cTn id="25" presetID="10" presetClass="entr" presetSubtype="0" fill="hold" grpId="4" nodeType="clickEffect">
+                                  <p:stCondLst>
+                                    <p:cond delay="0"/>
+                                  </p:stCondLst>
+                                  <p:childTnLst>
+                                    <p:set>
+                                      <p:cBhvr>
+                                        <p:cTn id="26" dur="1" fill="hold">
+                                          <p:stCondLst>
+                                            <p:cond delay="0"/>
+                                          </p:stCondLst>
+                                        </p:cTn>
+                                        <p:tgtEl>
+                                          <p:spTgt spid="104"/>
+                                        </p:tgtEl>
+                                        <p:attrNameLst>
+                                          <p:attrName>style.visibility</p:attrName>
+                                        </p:attrNameLst>
+                                      </p:cBhvr>
+                                      <p:to>
+                                        <p:strVal val="visible"/>
+                                      </p:to>
+                                    </p:set>
+                                    <p:animEffect transition="in" filter="fade">
+                                      <p:cBhvr>
+                                        <p:cTn id="27" dur="500"/>
+                                        <p:tgtEl>
+                                          <p:spTgt spid="104"/>
+                                        </p:tgtEl>
+                                      </p:cBhvr>
+                                    </p:animEffect>
+                                  </p:childTnLst>
+                                </p:cTn>
+                              </p:par>
+                            </p:childTnLst>
+                          </p:cTn>
+                        </p:par>
+                        <p:par>
+                          <p:cTn id="28" fill="hold">
+                            <p:stCondLst>
+                              <p:cond delay="0"/>
+                            </p:stCondLst>
+                            <p:childTnLst>
+                              <p:par>
+                                <p:cTn id="29" presetID="10" presetClass="entr" presetSubtype="0" fill="hold" grpId="5" nodeType="withEffect">
+                                  <p:stCondLst>
+                                    <p:cond delay="0"/>
+                                  </p:stCondLst>
+                                  <p:childTnLst>
+                                    <p:set>
+                                      <p:cBhvr>
+                                        <p:cTn id="30" dur="1" fill="hold">
+                                          <p:stCondLst>
+                                            <p:cond delay="0"/>
+                                          </p:stCondLst>
+                                        </p:cTn>
+                                        <p:tgtEl>
+                                          <p:spTgt spid="105"/>
+                                        </p:tgtEl>
+                                        <p:attrNameLst>
+                                          <p:attrName>style.visibility</p:attrName>
+                                        </p:attrNameLst>
+                                      </p:cBhvr>
+                                      <p:to>
+                                        <p:strVal val="visible"/>
+                                      </p:to>
+                                    </p:set>
+                                    <p:animEffect transition="in" filter="fade">
+                                      <p:cBhvr>
+                                        <p:cTn id="31" dur="500"/>
+                                        <p:tgtEl>
+                                          <p:spTgt spid="105"/>
+                                        </p:tgtEl>
+                                      </p:cBhvr>
+                                    </p:animEffect>
+                                  </p:childTnLst>
+                                </p:cTn>
+                              </p:par>
+                            </p:childTnLst>
+                          </p:cTn>
+                        </p:par>
+                        <p:par>
+                          <p:cTn id="32" fill="hold">
+                            <p:stCondLst>
+                              <p:cond delay="0"/>
+                            </p:stCondLst>
+                            <p:childTnLst>
+                              <p:par>
+                                <p:cTn id="33" presetID="10" presetClass="entr" presetSubtype="0" fill="hold" grpId="6" nodeType="withEffect">
+                                  <p:stCondLst>
+                                    <p:cond delay="0"/>
+                                  </p:stCondLst>
+                                  <p:childTnLst>
+                                    <p:set>
+                                      <p:cBhvr>
+                                        <p:cTn id="34" dur="1" fill="hold">
+                                          <p:stCondLst>
+                                            <p:cond delay="0"/>
+                                          </p:stCondLst>
+                                        </p:cTn>
+                                        <p:tgtEl>
+                                          <p:spTgt spid="106"/>
+                                        </p:tgtEl>
+                                        <p:attrNameLst>
+                                          <p:attrName>style.visibility</p:attrName>
+                                        </p:attrNameLst>
+                                      </p:cBhvr>
+                                      <p:to>
+                                        <p:strVal val="visible"/>
+                                      </p:to>
+                                    </p:set>
+                                    <p:animEffect transition="in" filter="fade">
+                                      <p:cBhvr>
+                                        <p:cTn id="35" dur="500"/>
+                                        <p:tgtEl>
+                                          <p:spTgt spid="106"/>
+                                        </p:tgtEl>
+                                      </p:cBhvr>
+                                    </p:animEffect>
+                                  </p:childTnLst>
+                                </p:cTn>
+                              </p:par>
+                            </p:childTnLst>
+                          </p:cTn>
+                        </p:par>
+                      </p:childTnLst>
+                    </p:cTn>
+                  </p:par>
+                </p:childTnLst>
+              </p:cTn>
+              <p:prevCondLst>
+                <p:cond evt="onPrev" delay="0">
+                  <p:tgtEl>
+                    <p:sldTgt/>
+                  </p:tgtEl>
+                </p:cond>
+              </p:prevCondLst>
+              <p:nextCondLst>
+                <p:cond evt="onNext" delay="0">
+                  <p:tgtEl>
+                    <p:sldTgt/>
+                  </p:tgtEl>
+                </p:cond>
+              </p:nextCondLst>
+            </p:seq>
+          </p:childTnLst>
+        </p:cTn>
+      </p:par>
+    </p:tnLst>
+    <p:bldLst>
+      <p:bldP spid="100" grpId="0"/>
+      <p:bldP spid="101" grpId="1"/>
+      <p:bldP spid="102" grpId="2"/>
+      <p:bldP spid="103" grpId="3"/>
+      <p:bldP spid="104" grpId="4"/>
+      <p:bldP spid="105" grpId="5"/>
+      <p:bldP spid="106" grpId="6"/>
+    </p:bldLst>
+  </p:timing>
 </p:sld>
 </file>
 
@@ -29369,207 +29761,39 @@
       </p:sp>
       <p:sp>
         <p:nvSpPr>
-          <p:cNvPr id="100" name="S100"/>
+          <p:cNvPr id="100" name="FunnelBottom"/>
           <p:cNvSpPr/>
           <p:nvPr/>
         </p:nvSpPr>
         <p:spPr>
           <a:xfrm>
-            <a:off x="501999" y="1139547"/>
-            <a:ext cx="1900000" cy="994000"/>
-          </a:xfrm>
-          <a:prstGeom prst="rect">
-            <a:avLst/>
-          </a:prstGeom>
-          <a:solidFill>
-            <a:srgbClr val="F0E6CE"/>
-          </a:solidFill>
-          <a:ln w="12700">
-            <a:solidFill>
-              <a:srgbClr val="C9B991"/>
-            </a:solidFill>
-          </a:ln>
-        </p:spPr>
-        <p:txBody>
-          <a:bodyPr wrap="square" lIns="91440" tIns="45720" rIns="91440" bIns="45720" anchor="ctr"/>
-          <a:lstStyle/>
-          <a:p>
-            <a:pPr algn="ctr">
-              <a:buNone/>
-            </a:pPr>
-            <a:r>
-              <a:rPr lang="en-US" sz="2000" b="1" i="0" dirty="0">
-                <a:solidFill>
-                  <a:srgbClr val="5C4826"/>
-                </a:solidFill>
-              </a:rPr>
-              <a:t>system</a:t>
-            </a:r>
-          </a:p>
-        </p:txBody>
-      </p:sp>
-      <p:cxnSp>
-        <p:nvCxnSpPr>
-          <p:cNvPr id="101" name="L101"/>
-          <p:cNvCxnSpPr/>
-          <p:nvPr/>
-        </p:nvCxnSpPr>
-        <p:spPr>
-          <a:xfrm>
-            <a:off x="2402000" y="1636547"/>
-            <a:ext cx="180000" cy="0"/>
-          </a:xfrm>
-          <a:prstGeom prst="straightConnector1">
-            <a:avLst/>
-          </a:prstGeom>
-          <a:ln w="38100">
-            <a:solidFill>
-              <a:srgbClr val="8E6F3E"/>
-            </a:solidFill>
-            <a:tailEnd type="triangle" w="med" len="med"/>
-          </a:ln>
-        </p:spPr>
-      </p:cxnSp>
-      <p:sp>
-        <p:nvSpPr>
-          <p:cNvPr id="102" name="S102"/>
-          <p:cNvSpPr/>
-          <p:nvPr/>
-        </p:nvSpPr>
-        <p:spPr>
-          <a:xfrm>
-            <a:off x="2582000" y="1139547"/>
-            <a:ext cx="1900000" cy="994000"/>
-          </a:xfrm>
-          <a:prstGeom prst="rect">
-            <a:avLst/>
-          </a:prstGeom>
-          <a:solidFill>
-            <a:srgbClr val="EBDFC2"/>
-          </a:solidFill>
-          <a:ln w="12700">
-            <a:solidFill>
-              <a:srgbClr val="C9B991"/>
-            </a:solidFill>
-          </a:ln>
-        </p:spPr>
-        <p:txBody>
-          <a:bodyPr wrap="square" lIns="91440" tIns="45720" rIns="91440" bIns="45720" anchor="ctr"/>
-          <a:lstStyle/>
-          <a:p>
-            <a:pPr algn="ctr">
-              <a:buNone/>
-            </a:pPr>
-            <a:r>
-              <a:rPr lang="en-US" sz="2000" b="1" i="0" dirty="0">
-                <a:solidFill>
-                  <a:srgbClr val="5C4826"/>
-                </a:solidFill>
-              </a:rPr>
-              <a:t>subsystem</a:t>
-            </a:r>
-          </a:p>
-        </p:txBody>
-      </p:sp>
-      <p:cxnSp>
-        <p:nvCxnSpPr>
-          <p:cNvPr id="103" name="L103"/>
-          <p:cNvCxnSpPr/>
-          <p:nvPr/>
-        </p:nvCxnSpPr>
-        <p:spPr>
-          <a:xfrm>
-            <a:off x="4482000" y="1636547"/>
-            <a:ext cx="180000" cy="0"/>
-          </a:xfrm>
-          <a:prstGeom prst="straightConnector1">
-            <a:avLst/>
-          </a:prstGeom>
-          <a:ln w="38100">
-            <a:solidFill>
-              <a:srgbClr val="8E6F3E"/>
-            </a:solidFill>
-            <a:tailEnd type="triangle" w="med" len="med"/>
-          </a:ln>
-        </p:spPr>
-      </p:cxnSp>
-      <p:sp>
-        <p:nvSpPr>
-          <p:cNvPr id="104" name="S104"/>
-          <p:cNvSpPr/>
-          <p:nvPr/>
-        </p:nvSpPr>
-        <p:spPr>
-          <a:xfrm>
-            <a:off x="4662000" y="1139547"/>
-            <a:ext cx="1900000" cy="994000"/>
-          </a:xfrm>
-          <a:prstGeom prst="rect">
-            <a:avLst/>
-          </a:prstGeom>
-          <a:solidFill>
-            <a:srgbClr val="E4D6B0"/>
-          </a:solidFill>
-          <a:ln w="12700">
-            <a:solidFill>
-              <a:srgbClr val="C9B991"/>
-            </a:solidFill>
-          </a:ln>
-        </p:spPr>
-        <p:txBody>
-          <a:bodyPr wrap="square" lIns="91440" tIns="45720" rIns="91440" bIns="45720" anchor="ctr"/>
-          <a:lstStyle/>
-          <a:p>
-            <a:pPr algn="ctr">
-              <a:buNone/>
-            </a:pPr>
-            <a:r>
-              <a:rPr lang="en-US" sz="2000" b="1" i="0" dirty="0">
-                <a:solidFill>
-                  <a:srgbClr val="5C4826"/>
-                </a:solidFill>
-              </a:rPr>
-              <a:t>component</a:t>
-            </a:r>
-          </a:p>
-        </p:txBody>
-      </p:sp>
-      <p:cxnSp>
-        <p:nvCxnSpPr>
-          <p:cNvPr id="105" name="L105"/>
-          <p:cNvCxnSpPr/>
-          <p:nvPr/>
-        </p:nvCxnSpPr>
-        <p:spPr>
-          <a:xfrm>
-            <a:off x="6562000" y="1636547"/>
-            <a:ext cx="180000" cy="0"/>
-          </a:xfrm>
-          <a:prstGeom prst="straightConnector1">
-            <a:avLst/>
-          </a:prstGeom>
-          <a:ln w="38100">
-            <a:solidFill>
-              <a:srgbClr val="8E6F3E"/>
-            </a:solidFill>
-            <a:tailEnd type="triangle" w="med" len="med"/>
-          </a:ln>
-        </p:spPr>
-      </p:cxnSp>
-      <p:sp>
-        <p:nvSpPr>
-          <p:cNvPr id="106" name="S106"/>
-          <p:cNvSpPr/>
-          <p:nvPr/>
-        </p:nvSpPr>
-        <p:spPr>
-          <a:xfrm>
-            <a:off x="6742000" y="1139547"/>
-            <a:ext cx="1900000" cy="994000"/>
-          </a:xfrm>
-          <a:prstGeom prst="rect">
-            <a:avLst/>
-          </a:prstGeom>
+            <a:off x="2172000" y="1200000"/>
+            <a:ext cx="4800000" cy="760000"/>
+          </a:xfrm>
+          <a:custGeom>
+            <a:avLst/>
+            <a:gdLst/>
+            <a:ahLst/>
+            <a:cxnLst/>
+            <a:rect l="l" t="t" r="r" b="b"/>
+            <a:pathLst>
+              <a:path w="4800000" h="760000">
+                <a:moveTo>
+                  <a:pt x="0" y="0"/>
+                </a:moveTo>
+                <a:lnTo>
+                  <a:pt x="4800000" y="0"/>
+                </a:lnTo>
+                <a:lnTo>
+                  <a:pt x="4300000" y="760000"/>
+                </a:lnTo>
+                <a:lnTo>
+                  <a:pt x="500000" y="760000"/>
+                </a:lnTo>
+                <a:close/>
+              </a:path>
+            </a:pathLst>
+          </a:custGeom>
           <a:solidFill>
             <a:srgbClr val="F5F1E8"/>
           </a:solidFill>
@@ -29587,26 +29811,113 @@
               <a:buNone/>
             </a:pPr>
             <a:r>
-              <a:rPr lang="en-US" sz="2000" b="1" i="0" dirty="0">
+              <a:rPr lang="en-US" sz="1600" b="1" i="0" dirty="0">
                 <a:solidFill>
                   <a:srgbClr val="5C4826"/>
                 </a:solidFill>
               </a:rPr>
-              <a:t>object / function / data structure</a:t>
-            </a:r>
-          </a:p>
-        </p:txBody>
-      </p:sp>
-      <p:sp>
-        <p:nvSpPr>
-          <p:cNvPr id="107" name="S107"/>
+              <a:t>COMPONENT</a:t>
+            </a:r>
+            <a:r>
+              <a:rPr lang="en-US" sz="1600" b="0" i="1" dirty="0">
+                <a:solidFill>
+                  <a:srgbClr val="555960"/>
+                </a:solidFill>
+              </a:rPr>
+              <a:t xml:space="preserve"> — opened at the funnel bottom</a:t>
+            </a:r>
+          </a:p>
+        </p:txBody>
+      </p:sp>
+      <p:cxnSp>
+        <p:nvCxnSpPr>
+          <p:cNvPr id="101" name="L101"/>
+          <p:cNvCxnSpPr/>
+          <p:nvPr/>
+        </p:nvCxnSpPr>
+        <p:spPr>
+          <a:xfrm>
+            <a:off x="4572000" y="2040000"/>
+            <a:ext cx="0" cy="400000"/>
+          </a:xfrm>
+          <a:prstGeom prst="straightConnector1">
+            <a:avLst/>
+          </a:prstGeom>
+          <a:ln w="38100">
+            <a:solidFill>
+              <a:srgbClr val="8E6F3E"/>
+            </a:solidFill>
+            <a:tailEnd type="triangle" w="med" len="med"/>
+          </a:ln>
+        </p:spPr>
+      </p:cxnSp>
+      <p:sp>
+        <p:nvSpPr>
+          <p:cNvPr id="102" name="Entities"/>
           <p:cNvSpPr/>
           <p:nvPr/>
         </p:nvSpPr>
         <p:spPr>
           <a:xfrm>
-            <a:off x="971999" y="2772547"/>
-            <a:ext cx="7200000" cy="880400"/>
+            <a:off x="1872000" y="2500000"/>
+            <a:ext cx="5400000" cy="900000"/>
+          </a:xfrm>
+          <a:prstGeom prst="rect">
+            <a:avLst/>
+          </a:prstGeom>
+          <a:solidFill>
+            <a:srgbClr val="FBF8F2"/>
+          </a:solidFill>
+          <a:ln w="12700">
+            <a:solidFill>
+              <a:srgbClr val="C9B991"/>
+            </a:solidFill>
+          </a:ln>
+        </p:spPr>
+        <p:txBody>
+          <a:bodyPr wrap="square" lIns="91440" tIns="45720" rIns="91440" bIns="45720" anchor="ctr"/>
+          <a:lstStyle/>
+          <a:p>
+            <a:pPr algn="ctr">
+              <a:buNone/>
+            </a:pPr>
+            <a:r>
+              <a:rPr lang="en-US" sz="1800" b="1" i="0" dirty="0">
+                <a:solidFill>
+                  <a:srgbClr val="5C4826"/>
+                </a:solidFill>
+              </a:rPr>
+              <a:t>entities we can reason about directly</a:t>
+            </a:r>
+          </a:p>
+          <a:p>
+            <a:pPr algn="ctr">
+              <a:spcBef>
+                <a:spcPts val="80"/>
+              </a:spcBef>
+              <a:buNone/>
+            </a:pPr>
+            <a:r>
+              <a:rPr lang="en-US" sz="1600" b="0" i="0" dirty="0">
+                <a:solidFill>
+                  <a:srgbClr val="000000"/>
+                </a:solidFill>
+              </a:rPr>
+              <a:t>object · function · data structure · small collaboration</a:t>
+            </a:r>
+          </a:p>
+        </p:txBody>
+      </p:sp>
+      <p:sp>
+        <p:nvSpPr>
+          <p:cNvPr id="103" name="StopBanner"/>
+          <p:cNvSpPr/>
+          <p:nvPr/>
+        </p:nvSpPr>
+        <p:spPr>
+          <a:xfrm>
+            <a:off x="971999" y="3750000"/>
+            <a:ext cx="7200000" cy="990000"/>
           </a:xfrm>
           <a:prstGeom prst="rect">
             <a:avLst/>
@@ -29626,49 +29937,12 @@
               <a:buNone/>
             </a:pPr>
             <a:r>
-              <a:rPr lang="en-US" sz="2400" b="1" i="0" dirty="0">
+              <a:rPr lang="en-US" sz="2200" b="1" i="0" dirty="0">
                 <a:solidFill>
                   <a:srgbClr val="FFFFFF"/>
                 </a:solidFill>
               </a:rPr>
-              <a:t>STOP when the remaining entities are small enough to reason about directly.</a:t>
-            </a:r>
-          </a:p>
-        </p:txBody>
-      </p:sp>
-      <p:sp>
-        <p:nvSpPr>
-          <p:cNvPr id="108" name="Sub"/>
-          <p:cNvSpPr txBox="1"/>
-          <p:nvPr/>
-        </p:nvSpPr>
-        <p:spPr>
-          <a:xfrm>
-            <a:off x="277147" y="3908547"/>
-            <a:ext cx="8589704" cy="568000"/>
-          </a:xfrm>
-          <a:prstGeom prst="rect">
-            <a:avLst/>
-          </a:prstGeom>
-          <a:noFill/>
-          <a:ln>
-            <a:noFill/>
-          </a:ln>
-        </p:spPr>
-        <p:txBody>
-          <a:bodyPr wrap="square" lIns="0" tIns="0" rIns="0" bIns="0" anchor="t"/>
-          <a:lstStyle/>
-          <a:p>
-            <a:pPr algn="ctr">
-              <a:buNone/>
-            </a:pPr>
-            <a:r>
-              <a:rPr lang="en-US" sz="2000" b="0" i="1" dirty="0">
-                <a:solidFill>
-                  <a:srgbClr val="555960"/>
-                </a:solidFill>
-              </a:rPr>
-              <a:t>Further decomposition no longer makes the engineering problem easier to understand.</a:t>
+              <a:t>Stop when further decomposition no longer makes the engineering problem easier to reason about.</a:t>
             </a:r>
           </a:p>
         </p:txBody>
@@ -29681,7 +29955,7 @@
         </p:nvSpPr>
         <p:spPr>
           <a:xfrm>
-            <a:off x="1828800" y="4760547"/>
+            <a:off x="1828800" y="5030000"/>
             <a:ext cx="5486400" cy="795199"/>
           </a:xfrm>
           <a:prstGeom prst="rect">

</xml_diff>

<commit_message>
course(design): patch 2 — verb precision (11/13/24), 15-19 pacing notes, slide 29 rebuilt as cheapest-model-is-implementation + extract-the-model
</commit_message>
<xml_diff>
--- a/course/lectures/act-1-foundations/07-design/1-7-Design.pptx
+++ b/course/lectures/act-1-foundations/07-design/1-7-Design.pptx
@@ -673,6 +673,29 @@
               <a:t xml:space="preserve">- Do not drift into consistency yet.</a:t>
             </a:r>
           </a:p>
+          <a:p>
+            <a:endParaRPr dirty="0"/>
+          </a:p>
+          <a:p>
+            <a:r>
+              <a:rPr b="1" dirty="0"/>
+              <a:t xml:space="preserve">PACING: </a:t>
+            </a:r>
+            <a:r>
+              <a:rPr dirty="0"/>
+              <a:t>Dwell here. This is the anchor example of the five — take the time to work the authority question fully.</a:t>
+            </a:r>
+          </a:p>
+          <a:p>
+            <a:r>
+              <a:rPr b="1" dirty="0"/>
+              <a:t xml:space="preserve">METRIC SEEDS: </a:t>
+            </a:r>
+            <a:r>
+              <a:rPr dirty="0"/>
+              <a:t>authoritative writers / coordination / conflicts. A seed for the later Metrics lecture — let students use it naturally now; do not explain metrics theory here.</a:t>
+            </a:r>
+          </a:p>
         </p:txBody>
       </p:sp>
     </p:spTree>
@@ -745,6 +768,29 @@
               <a:t xml:space="preserve">- If CAP comes up, keep it subordinate and technically correct.</a:t>
             </a:r>
           </a:p>
+          <a:p>
+            <a:endParaRPr dirty="0"/>
+          </a:p>
+          <a:p>
+            <a:r>
+              <a:rPr b="1" dirty="0"/>
+              <a:t xml:space="preserve">PACING: </a:t>
+            </a:r>
+            <a:r>
+              <a:rPr dirty="0"/>
+              <a:t>Move briskly. A quick contrast — the point is that required semantics, not replication topology, decide; do not linger.</a:t>
+            </a:r>
+          </a:p>
+          <a:p>
+            <a:r>
+              <a:rPr b="1" dirty="0"/>
+              <a:t xml:space="preserve">METRIC SEEDS: </a:t>
+            </a:r>
+            <a:r>
+              <a:rPr dirty="0"/>
+              <a:t>stale-read window / propagation latency / round-trips. A seed for the later Metrics lecture — let students use it naturally now; do not explain metrics theory here.</a:t>
+            </a:r>
+          </a:p>
         </p:txBody>
       </p:sp>
     </p:spTree>
@@ -811,6 +857,29 @@
               <a:t xml:space="preserve">- The deferred side takes on retries, idempotence, and ordering.</a:t>
             </a:r>
           </a:p>
+          <a:p>
+            <a:endParaRPr dirty="0"/>
+          </a:p>
+          <a:p>
+            <a:r>
+              <a:rPr b="1" dirty="0"/>
+              <a:t xml:space="preserve">PACING: </a:t>
+            </a:r>
+            <a:r>
+              <a:rPr dirty="0"/>
+              <a:t>Dwell here. The second anchor — work the immediate-vs-deferred tradeoff and the concerns the deferred side inherits.</a:t>
+            </a:r>
+          </a:p>
+          <a:p>
+            <a:r>
+              <a:rPr b="1" dirty="0"/>
+              <a:t xml:space="preserve">METRIC SEEDS: </a:t>
+            </a:r>
+            <a:r>
+              <a:rPr dirty="0"/>
+              <a:t>critical-path latency / queue depth / retries. A seed for the later Metrics lecture — let students use it naturally now; do not explain metrics theory here.</a:t>
+            </a:r>
+          </a:p>
         </p:txBody>
       </p:sp>
     </p:spTree>
@@ -1039,6 +1108,29 @@
               <a:t xml:space="preserve">- An additional layer is not automatically sophisticated or better.</a:t>
             </a:r>
           </a:p>
+          <a:p>
+            <a:endParaRPr dirty="0"/>
+          </a:p>
+          <a:p>
+            <a:r>
+              <a:rPr b="1" dirty="0"/>
+              <a:t xml:space="preserve">PACING: </a:t>
+            </a:r>
+            <a:r>
+              <a:rPr dirty="0"/>
+              <a:t>Move briskly. A short beat on what indirection buys and the complexity it spends; do not over-develop.</a:t>
+            </a:r>
+          </a:p>
+          <a:p>
+            <a:r>
+              <a:rPr b="1" dirty="0"/>
+              <a:t xml:space="preserve">METRIC SEEDS: </a:t>
+            </a:r>
+            <a:r>
+              <a:rPr dirty="0"/>
+              <a:t>dependency crossings / fan-in / fan-out. A seed for the later Metrics lecture — let students use it naturally now; do not explain metrics theory here.</a:t>
+            </a:r>
+          </a:p>
         </p:txBody>
       </p:sp>
     </p:spTree>
@@ -1109,6 +1201,29 @@
             <a:r>
               <a:rPr dirty="0"/>
               <a:t xml:space="preserve">- Acknowledge the boundary: if a decomposition creates consequential responsibilities and boundaries, Architecture has recurred at this scope (the slide-9 funnel). Not all decomposition is Design — do not let the example imply that it is.</a:t>
+            </a:r>
+          </a:p>
+          <a:p>
+            <a:endParaRPr dirty="0"/>
+          </a:p>
+          <a:p>
+            <a:r>
+              <a:rPr b="1" dirty="0"/>
+              <a:t xml:space="preserve">PACING: </a:t>
+            </a:r>
+            <a:r>
+              <a:rPr dirty="0"/>
+              <a:t>Use as the culmination, not a sixth peer example. Pull the five together — each was a mechanism choice with measurable consequences.</a:t>
+            </a:r>
+          </a:p>
+          <a:p>
+            <a:r>
+              <a:rPr b="1" dirty="0"/>
+              <a:t xml:space="preserve">METRIC SEEDS: </a:t>
+            </a:r>
+            <a:r>
+              <a:rPr dirty="0"/>
+              <a:t>change impact / interface stability / modules touched. A seed for the later Metrics lecture — let students use it naturally now; do not explain metrics theory here.</a:t>
             </a:r>
           </a:p>
         </p:txBody>
@@ -15438,7 +15553,7 @@
                   <a:srgbClr val="000000"/>
                 </a:solidFill>
               </a:rPr>
-              <a:t>Velocity changes what we can see</a:t>
+              <a:t>Sometimes the cheapest model is the implementation</a:t>
             </a:r>
           </a:p>
         </p:txBody>
@@ -15468,14 +15583,53 @@
       </p:sp>
       <p:sp>
         <p:nvSpPr>
-          <p:cNvPr id="100" name="Label"/>
+          <p:cNvPr id="100" name="OpenDecision"/>
+          <p:cNvSpPr/>
+          <p:nvPr/>
+        </p:nvSpPr>
+        <p:spPr>
+          <a:xfrm>
+            <a:off x="1260000" y="800000"/>
+            <a:ext cx="2600000" cy="420000"/>
+          </a:xfrm>
+          <a:prstGeom prst="rect">
+            <a:avLst/>
+          </a:prstGeom>
+          <a:solidFill>
+            <a:srgbClr val="8E6F3E"/>
+          </a:solidFill>
+          <a:ln>
+            <a:noFill/>
+          </a:ln>
+        </p:spPr>
+        <p:txBody>
+          <a:bodyPr wrap="square" lIns="91440" tIns="45720" rIns="91440" bIns="45720" anchor="ctr"/>
+          <a:lstStyle/>
+          <a:p>
+            <a:pPr algn="ctr">
+              <a:buNone/>
+            </a:pPr>
+            <a:r>
+              <a:rPr lang="en-US" sz="2000" b="1" i="0" dirty="0">
+                <a:solidFill>
+                  <a:srgbClr val="FFFFFF"/>
+                </a:solidFill>
+              </a:rPr>
+              <a:t>OPEN DECISION</a:t>
+            </a:r>
+          </a:p>
+        </p:txBody>
+      </p:sp>
+      <p:sp>
+        <p:nvSpPr>
+          <p:cNvPr id="101" name="Caption"/>
           <p:cNvSpPr txBox="1"/>
           <p:nvPr/>
         </p:nvSpPr>
         <p:spPr>
           <a:xfrm>
-            <a:off x="277147" y="1019940"/>
-            <a:ext cx="8589704" cy="494999"/>
+            <a:off x="1060000" y="1250000"/>
+            <a:ext cx="3000000" cy="260000"/>
           </a:xfrm>
           <a:prstGeom prst="rect">
             <a:avLst/>
@@ -15493,26 +15647,142 @@
               <a:buNone/>
             </a:pPr>
             <a:r>
-              <a:rPr lang="en-US" sz="2400" b="1" i="0" dirty="0">
-                <a:solidFill>
-                  <a:srgbClr val="8E6F3E"/>
-                </a:solidFill>
-              </a:rPr>
-              <a:t>SLOW</a:t>
-            </a:r>
-          </a:p>
-        </p:txBody>
-      </p:sp>
-      <p:sp>
-        <p:nvSpPr>
-          <p:cNvPr id="101" name="S101"/>
+              <a:rPr lang="en-US" sz="1400" b="0" i="1" dirty="0">
+                <a:solidFill>
+                  <a:srgbClr val="555960"/>
+                </a:solidFill>
+              </a:rPr>
+              <a:t>What do we need to know?</a:t>
+            </a:r>
+          </a:p>
+        </p:txBody>
+      </p:sp>
+      <p:sp>
+        <p:nvSpPr>
+          <p:cNvPr id="102" name="C"/>
           <p:cNvSpPr/>
           <p:nvPr/>
         </p:nvSpPr>
         <p:spPr>
           <a:xfrm>
-            <a:off x="274320" y="1589939"/>
-            <a:ext cx="8595360" cy="1350000"/>
+            <a:off x="2546000" y="1510000"/>
+            <a:ext cx="28000" cy="130000"/>
+          </a:xfrm>
+          <a:prstGeom prst="rect">
+            <a:avLst/>
+          </a:prstGeom>
+          <a:solidFill>
+            <a:srgbClr val="8E6F3E"/>
+          </a:solidFill>
+          <a:ln>
+            <a:noFill/>
+          </a:ln>
+        </p:spPr>
+        <p:txBody>
+          <a:bodyPr/>
+          <a:lstStyle/>
+          <a:p>
+            <a:endParaRPr/>
+          </a:p>
+        </p:txBody>
+      </p:sp>
+      <p:sp>
+        <p:nvSpPr>
+          <p:cNvPr id="103" name="C"/>
+          <p:cNvSpPr/>
+          <p:nvPr/>
+        </p:nvSpPr>
+        <p:spPr>
+          <a:xfrm>
+            <a:off x="1500000" y="1640000"/>
+            <a:ext cx="2120000" cy="24000"/>
+          </a:xfrm>
+          <a:prstGeom prst="rect">
+            <a:avLst/>
+          </a:prstGeom>
+          <a:solidFill>
+            <a:srgbClr val="8E6F3E"/>
+          </a:solidFill>
+          <a:ln>
+            <a:noFill/>
+          </a:ln>
+        </p:spPr>
+        <p:txBody>
+          <a:bodyPr/>
+          <a:lstStyle/>
+          <a:p>
+            <a:endParaRPr/>
+          </a:p>
+        </p:txBody>
+      </p:sp>
+      <p:sp>
+        <p:nvSpPr>
+          <p:cNvPr id="104" name="C"/>
+          <p:cNvSpPr/>
+          <p:nvPr/>
+        </p:nvSpPr>
+        <p:spPr>
+          <a:xfrm>
+            <a:off x="1486000" y="1640000"/>
+            <a:ext cx="28000" cy="170000"/>
+          </a:xfrm>
+          <a:prstGeom prst="rect">
+            <a:avLst/>
+          </a:prstGeom>
+          <a:solidFill>
+            <a:srgbClr val="8E6F3E"/>
+          </a:solidFill>
+          <a:ln>
+            <a:noFill/>
+          </a:ln>
+        </p:spPr>
+        <p:txBody>
+          <a:bodyPr/>
+          <a:lstStyle/>
+          <a:p>
+            <a:endParaRPr/>
+          </a:p>
+        </p:txBody>
+      </p:sp>
+      <p:sp>
+        <p:nvSpPr>
+          <p:cNvPr id="105" name="C"/>
+          <p:cNvSpPr/>
+          <p:nvPr/>
+        </p:nvSpPr>
+        <p:spPr>
+          <a:xfrm>
+            <a:off x="3606000" y="1640000"/>
+            <a:ext cx="28000" cy="170000"/>
+          </a:xfrm>
+          <a:prstGeom prst="rect">
+            <a:avLst/>
+          </a:prstGeom>
+          <a:solidFill>
+            <a:srgbClr val="8E6F3E"/>
+          </a:solidFill>
+          <a:ln>
+            <a:noFill/>
+          </a:ln>
+        </p:spPr>
+        <p:txBody>
+          <a:bodyPr/>
+          <a:lstStyle/>
+          <a:p>
+            <a:endParaRPr/>
+          </a:p>
+        </p:txBody>
+      </p:sp>
+      <p:sp>
+        <p:nvSpPr>
+          <p:cNvPr id="106" name="MechA"/>
+          <p:cNvSpPr/>
+          <p:nvPr/>
+        </p:nvSpPr>
+        <p:spPr>
+          <a:xfrm>
+            <a:off x="640000" y="1810000"/>
+            <a:ext cx="1720000" cy="520000"/>
           </a:xfrm>
           <a:prstGeom prst="rect">
             <a:avLst/>
@@ -15527,86 +15797,132 @@
           </a:ln>
         </p:spPr>
         <p:txBody>
-          <a:bodyPr wrap="square" lIns="91440" tIns="45720" rIns="91440" bIns="45720" anchor="ctr"/>
+          <a:bodyPr wrap="square" lIns="45720" tIns="45720" rIns="45720" bIns="45720" anchor="ctr"/>
           <a:lstStyle/>
           <a:p>
             <a:pPr algn="ctr">
               <a:buNone/>
             </a:pPr>
             <a:r>
-              <a:rPr lang="en-US" sz="1750" b="0" i="0" dirty="0">
+              <a:rPr lang="en-US" sz="1600" b="1" i="0" dirty="0">
                 <a:solidFill>
                   <a:srgbClr val="000000"/>
                 </a:solidFill>
               </a:rPr>
-              <a:t>FAIL A → fix → local        FAIL B → fix → local        FAIL C → fix → local</a:t>
-            </a:r>
-          </a:p>
+              <a:t>MECHANISM A</a:t>
+            </a:r>
+          </a:p>
+        </p:txBody>
+      </p:sp>
+      <p:sp>
+        <p:nvSpPr>
+          <p:cNvPr id="107" name="MechB"/>
+          <p:cNvSpPr/>
+          <p:nvPr/>
+        </p:nvSpPr>
+        <p:spPr>
+          <a:xfrm>
+            <a:off x="2760000" y="1810000"/>
+            <a:ext cx="1720000" cy="520000"/>
+          </a:xfrm>
+          <a:prstGeom prst="rect">
+            <a:avLst/>
+          </a:prstGeom>
+          <a:solidFill>
+            <a:srgbClr val="F5F1E8"/>
+          </a:solidFill>
+          <a:ln w="12700">
+            <a:solidFill>
+              <a:srgbClr val="C9B991"/>
+            </a:solidFill>
+          </a:ln>
+        </p:spPr>
+        <p:txBody>
+          <a:bodyPr wrap="square" lIns="45720" tIns="45720" rIns="45720" bIns="45720" anchor="ctr"/>
+          <a:lstStyle/>
           <a:p>
             <a:pPr algn="ctr">
-              <a:spcBef>
-                <a:spcPts val="120"/>
-              </a:spcBef>
-              <a:buNone/>
-            </a:pPr>
-            <a:r>
-              <a:rPr lang="en-US" sz="1700" b="0" i="1" dirty="0">
-                <a:solidFill>
-                  <a:srgbClr val="555960"/>
-                </a:solidFill>
-              </a:rPr>
-              <a:t>weeks apart · each looks like an isolated incident</a:t>
-            </a:r>
-          </a:p>
-        </p:txBody>
-      </p:sp>
-      <p:sp>
-        <p:nvSpPr>
-          <p:cNvPr id="102" name="Label"/>
-          <p:cNvSpPr txBox="1"/>
-          <p:nvPr/>
-        </p:nvSpPr>
-        <p:spPr>
-          <a:xfrm>
-            <a:off x="277147" y="3269940"/>
-            <a:ext cx="8589704" cy="494999"/>
-          </a:xfrm>
-          <a:prstGeom prst="rect">
-            <a:avLst/>
-          </a:prstGeom>
-          <a:noFill/>
+              <a:buNone/>
+            </a:pPr>
+            <a:r>
+              <a:rPr lang="en-US" sz="1600" b="1" i="0" dirty="0">
+                <a:solidFill>
+                  <a:srgbClr val="000000"/>
+                </a:solidFill>
+              </a:rPr>
+              <a:t>MECHANISM B</a:t>
+            </a:r>
+          </a:p>
+        </p:txBody>
+      </p:sp>
+      <p:sp>
+        <p:nvSpPr>
+          <p:cNvPr id="108" name="C"/>
+          <p:cNvSpPr/>
+          <p:nvPr/>
+        </p:nvSpPr>
+        <p:spPr>
+          <a:xfrm>
+            <a:off x="1486000" y="2330000"/>
+            <a:ext cx="28000" cy="110000"/>
+          </a:xfrm>
+          <a:prstGeom prst="rect">
+            <a:avLst/>
+          </a:prstGeom>
+          <a:solidFill>
+            <a:srgbClr val="8E6F3E"/>
+          </a:solidFill>
           <a:ln>
             <a:noFill/>
           </a:ln>
         </p:spPr>
         <p:txBody>
-          <a:bodyPr wrap="square" lIns="0" tIns="0" rIns="0" bIns="0" anchor="t"/>
-          <a:lstStyle/>
-          <a:p>
-            <a:pPr algn="ctr">
-              <a:buNone/>
-            </a:pPr>
-            <a:r>
-              <a:rPr lang="en-US" sz="2400" b="1" i="0" dirty="0">
-                <a:solidFill>
-                  <a:srgbClr val="8E6F3E"/>
-                </a:solidFill>
-              </a:rPr>
-              <a:t>DENSE</a:t>
-            </a:r>
-          </a:p>
-        </p:txBody>
-      </p:sp>
-      <p:sp>
-        <p:nvSpPr>
-          <p:cNvPr id="103" name="S103"/>
+          <a:bodyPr/>
+          <a:lstStyle/>
+          <a:p>
+            <a:endParaRPr/>
+          </a:p>
+        </p:txBody>
+      </p:sp>
+      <p:sp>
+        <p:nvSpPr>
+          <p:cNvPr id="109" name="C"/>
           <p:cNvSpPr/>
           <p:nvPr/>
         </p:nvSpPr>
         <p:spPr>
           <a:xfrm>
-            <a:off x="274320" y="3839940"/>
-            <a:ext cx="8595360" cy="1800000"/>
+            <a:off x="3606000" y="2330000"/>
+            <a:ext cx="28000" cy="110000"/>
+          </a:xfrm>
+          <a:prstGeom prst="rect">
+            <a:avLst/>
+          </a:prstGeom>
+          <a:solidFill>
+            <a:srgbClr val="8E6F3E"/>
+          </a:solidFill>
+          <a:ln>
+            <a:noFill/>
+          </a:ln>
+        </p:spPr>
+        <p:txBody>
+          <a:bodyPr/>
+          <a:lstStyle/>
+          <a:p>
+            <a:endParaRPr/>
+          </a:p>
+        </p:txBody>
+      </p:sp>
+      <p:sp>
+        <p:nvSpPr>
+          <p:cNvPr id="110" name="BuildA"/>
+          <p:cNvSpPr/>
+          <p:nvPr/>
+        </p:nvSpPr>
+        <p:spPr>
+          <a:xfrm>
+            <a:off x="640000" y="2440000"/>
+            <a:ext cx="1720000" cy="420000"/>
           </a:xfrm>
           <a:prstGeom prst="rect">
             <a:avLst/>
@@ -15616,70 +15932,79 @@
           </a:solidFill>
           <a:ln w="12700">
             <a:solidFill>
-              <a:srgbClr val="5C4826"/>
+              <a:srgbClr val="C9B991"/>
             </a:solidFill>
           </a:ln>
         </p:spPr>
         <p:txBody>
-          <a:bodyPr wrap="square" lIns="91440" tIns="45720" rIns="91440" bIns="45720" anchor="ctr"/>
+          <a:bodyPr wrap="square" lIns="45720" tIns="27432" rIns="45720" bIns="27432" anchor="ctr"/>
           <a:lstStyle/>
           <a:p>
             <a:pPr algn="ctr">
               <a:buNone/>
             </a:pPr>
             <a:r>
-              <a:rPr lang="en-US" sz="2200" b="0" i="0" dirty="0">
-                <a:solidFill>
-                  <a:srgbClr val="000000"/>
-                </a:solidFill>
-              </a:rPr>
-              <a:t>A   B   C     ·   in dense succession</a:t>
-            </a:r>
-          </a:p>
+              <a:rPr lang="en-US" sz="1400" b="1" i="0" dirty="0">
+                <a:solidFill>
+                  <a:srgbClr val="5C4826"/>
+                </a:solidFill>
+              </a:rPr>
+              <a:t>BUILD</a:t>
+            </a:r>
+          </a:p>
+        </p:txBody>
+      </p:sp>
+      <p:sp>
+        <p:nvSpPr>
+          <p:cNvPr id="111" name="BuildB"/>
+          <p:cNvSpPr/>
+          <p:nvPr/>
+        </p:nvSpPr>
+        <p:spPr>
+          <a:xfrm>
+            <a:off x="2760000" y="2440000"/>
+            <a:ext cx="1720000" cy="420000"/>
+          </a:xfrm>
+          <a:prstGeom prst="rect">
+            <a:avLst/>
+          </a:prstGeom>
+          <a:solidFill>
+            <a:srgbClr val="FBF8F2"/>
+          </a:solidFill>
+          <a:ln w="12700">
+            <a:solidFill>
+              <a:srgbClr val="C9B991"/>
+            </a:solidFill>
+          </a:ln>
+        </p:spPr>
+        <p:txBody>
+          <a:bodyPr wrap="square" lIns="45720" tIns="27432" rIns="45720" bIns="27432" anchor="ctr"/>
+          <a:lstStyle/>
           <a:p>
             <a:pPr algn="ctr">
-              <a:spcBef>
-                <a:spcPts val="120"/>
-              </a:spcBef>
-              <a:buNone/>
-            </a:pPr>
-            <a:r>
-              <a:rPr lang="en-US" sz="2400" b="1" i="0" dirty="0">
+              <a:buNone/>
+            </a:pPr>
+            <a:r>
+              <a:rPr lang="en-US" sz="1400" b="1" i="0" dirty="0">
                 <a:solidFill>
                   <a:srgbClr val="5C4826"/>
                 </a:solidFill>
               </a:rPr>
-              <a:t>RELATED?</a:t>
-            </a:r>
-          </a:p>
-          <a:p>
-            <a:pPr algn="ctr">
-              <a:spcBef>
-                <a:spcPts val="100"/>
-              </a:spcBef>
-              <a:buNone/>
-            </a:pPr>
-            <a:r>
-              <a:rPr lang="en-US" sz="2200" b="1" i="0" dirty="0">
-                <a:solidFill>
-                  <a:srgbClr val="8E6F3E"/>
-                </a:solidFill>
-              </a:rPr>
-              <a:t>↓  STRUCTURAL CAUSE</a:t>
-            </a:r>
-          </a:p>
-        </p:txBody>
-      </p:sp>
-      <p:sp>
-        <p:nvSpPr>
-          <p:cNvPr id="104" name="FooterBand"/>
+              <a:t>BUILD</a:t>
+            </a:r>
+          </a:p>
+        </p:txBody>
+      </p:sp>
+      <p:sp>
+        <p:nvSpPr>
+          <p:cNvPr id="112" name="C"/>
           <p:cNvSpPr/>
           <p:nvPr/>
         </p:nvSpPr>
         <p:spPr>
           <a:xfrm>
-            <a:off x="274320" y="5852160"/>
-            <a:ext cx="8595360" cy="566928"/>
+            <a:off x="1486000" y="2860000"/>
+            <a:ext cx="28000" cy="100000"/>
           </a:xfrm>
           <a:prstGeom prst="rect">
             <a:avLst/>
@@ -15692,6 +16017,262 @@
           </a:ln>
         </p:spPr>
         <p:txBody>
+          <a:bodyPr/>
+          <a:lstStyle/>
+          <a:p>
+            <a:endParaRPr/>
+          </a:p>
+        </p:txBody>
+      </p:sp>
+      <p:sp>
+        <p:nvSpPr>
+          <p:cNvPr id="113" name="C"/>
+          <p:cNvSpPr/>
+          <p:nvPr/>
+        </p:nvSpPr>
+        <p:spPr>
+          <a:xfrm>
+            <a:off x="3606000" y="2860000"/>
+            <a:ext cx="28000" cy="100000"/>
+          </a:xfrm>
+          <a:prstGeom prst="rect">
+            <a:avLst/>
+          </a:prstGeom>
+          <a:solidFill>
+            <a:srgbClr val="8E6F3E"/>
+          </a:solidFill>
+          <a:ln>
+            <a:noFill/>
+          </a:ln>
+        </p:spPr>
+        <p:txBody>
+          <a:bodyPr/>
+          <a:lstStyle/>
+          <a:p>
+            <a:endParaRPr/>
+          </a:p>
+        </p:txBody>
+      </p:sp>
+      <p:sp>
+        <p:nvSpPr>
+          <p:cNvPr id="114" name="MeasureA"/>
+          <p:cNvSpPr/>
+          <p:nvPr/>
+        </p:nvSpPr>
+        <p:spPr>
+          <a:xfrm>
+            <a:off x="640000" y="2960000"/>
+            <a:ext cx="1720000" cy="420000"/>
+          </a:xfrm>
+          <a:prstGeom prst="rect">
+            <a:avLst/>
+          </a:prstGeom>
+          <a:solidFill>
+            <a:srgbClr val="FBF8F2"/>
+          </a:solidFill>
+          <a:ln w="12700">
+            <a:solidFill>
+              <a:srgbClr val="C9B991"/>
+            </a:solidFill>
+          </a:ln>
+        </p:spPr>
+        <p:txBody>
+          <a:bodyPr wrap="square" lIns="45720" tIns="27432" rIns="45720" bIns="27432" anchor="ctr"/>
+          <a:lstStyle/>
+          <a:p>
+            <a:pPr algn="ctr">
+              <a:buNone/>
+            </a:pPr>
+            <a:r>
+              <a:rPr lang="en-US" sz="1400" b="1" i="0" dirty="0">
+                <a:solidFill>
+                  <a:srgbClr val="5C4826"/>
+                </a:solidFill>
+              </a:rPr>
+              <a:t>MEASURE</a:t>
+            </a:r>
+          </a:p>
+        </p:txBody>
+      </p:sp>
+      <p:sp>
+        <p:nvSpPr>
+          <p:cNvPr id="115" name="MeasureB"/>
+          <p:cNvSpPr/>
+          <p:nvPr/>
+        </p:nvSpPr>
+        <p:spPr>
+          <a:xfrm>
+            <a:off x="2760000" y="2960000"/>
+            <a:ext cx="1720000" cy="420000"/>
+          </a:xfrm>
+          <a:prstGeom prst="rect">
+            <a:avLst/>
+          </a:prstGeom>
+          <a:solidFill>
+            <a:srgbClr val="FBF8F2"/>
+          </a:solidFill>
+          <a:ln w="12700">
+            <a:solidFill>
+              <a:srgbClr val="C9B991"/>
+            </a:solidFill>
+          </a:ln>
+        </p:spPr>
+        <p:txBody>
+          <a:bodyPr wrap="square" lIns="45720" tIns="27432" rIns="45720" bIns="27432" anchor="ctr"/>
+          <a:lstStyle/>
+          <a:p>
+            <a:pPr algn="ctr">
+              <a:buNone/>
+            </a:pPr>
+            <a:r>
+              <a:rPr lang="en-US" sz="1400" b="1" i="0" dirty="0">
+                <a:solidFill>
+                  <a:srgbClr val="5C4826"/>
+                </a:solidFill>
+              </a:rPr>
+              <a:t>MEASURE</a:t>
+            </a:r>
+          </a:p>
+        </p:txBody>
+      </p:sp>
+      <p:sp>
+        <p:nvSpPr>
+          <p:cNvPr id="116" name="C"/>
+          <p:cNvSpPr/>
+          <p:nvPr/>
+        </p:nvSpPr>
+        <p:spPr>
+          <a:xfrm>
+            <a:off x="1486000" y="3380000"/>
+            <a:ext cx="28000" cy="120000"/>
+          </a:xfrm>
+          <a:prstGeom prst="rect">
+            <a:avLst/>
+          </a:prstGeom>
+          <a:solidFill>
+            <a:srgbClr val="8E6F3E"/>
+          </a:solidFill>
+          <a:ln>
+            <a:noFill/>
+          </a:ln>
+        </p:spPr>
+        <p:txBody>
+          <a:bodyPr/>
+          <a:lstStyle/>
+          <a:p>
+            <a:endParaRPr/>
+          </a:p>
+        </p:txBody>
+      </p:sp>
+      <p:sp>
+        <p:nvSpPr>
+          <p:cNvPr id="117" name="C"/>
+          <p:cNvSpPr/>
+          <p:nvPr/>
+        </p:nvSpPr>
+        <p:spPr>
+          <a:xfrm>
+            <a:off x="3606000" y="3380000"/>
+            <a:ext cx="28000" cy="120000"/>
+          </a:xfrm>
+          <a:prstGeom prst="rect">
+            <a:avLst/>
+          </a:prstGeom>
+          <a:solidFill>
+            <a:srgbClr val="8E6F3E"/>
+          </a:solidFill>
+          <a:ln>
+            <a:noFill/>
+          </a:ln>
+        </p:spPr>
+        <p:txBody>
+          <a:bodyPr/>
+          <a:lstStyle/>
+          <a:p>
+            <a:endParaRPr/>
+          </a:p>
+        </p:txBody>
+      </p:sp>
+      <p:sp>
+        <p:nvSpPr>
+          <p:cNvPr id="118" name="C"/>
+          <p:cNvSpPr/>
+          <p:nvPr/>
+        </p:nvSpPr>
+        <p:spPr>
+          <a:xfrm>
+            <a:off x="1500000" y="3500000"/>
+            <a:ext cx="2120000" cy="24000"/>
+          </a:xfrm>
+          <a:prstGeom prst="rect">
+            <a:avLst/>
+          </a:prstGeom>
+          <a:solidFill>
+            <a:srgbClr val="8E6F3E"/>
+          </a:solidFill>
+          <a:ln>
+            <a:noFill/>
+          </a:ln>
+        </p:spPr>
+        <p:txBody>
+          <a:bodyPr/>
+          <a:lstStyle/>
+          <a:p>
+            <a:endParaRPr/>
+          </a:p>
+        </p:txBody>
+      </p:sp>
+      <p:sp>
+        <p:nvSpPr>
+          <p:cNvPr id="119" name="C"/>
+          <p:cNvSpPr/>
+          <p:nvPr/>
+        </p:nvSpPr>
+        <p:spPr>
+          <a:xfrm>
+            <a:off x="2546000" y="3500000"/>
+            <a:ext cx="28000" cy="150000"/>
+          </a:xfrm>
+          <a:prstGeom prst="rect">
+            <a:avLst/>
+          </a:prstGeom>
+          <a:solidFill>
+            <a:srgbClr val="8E6F3E"/>
+          </a:solidFill>
+          <a:ln>
+            <a:noFill/>
+          </a:ln>
+        </p:spPr>
+        <p:txBody>
+          <a:bodyPr/>
+          <a:lstStyle/>
+          <a:p>
+            <a:endParaRPr/>
+          </a:p>
+        </p:txBody>
+      </p:sp>
+      <p:sp>
+        <p:nvSpPr>
+          <p:cNvPr id="120" name="Decide"/>
+          <p:cNvSpPr/>
+          <p:nvPr/>
+        </p:nvSpPr>
+        <p:spPr>
+          <a:xfrm>
+            <a:off x="1710000" y="3650000"/>
+            <a:ext cx="1700000" cy="400000"/>
+          </a:xfrm>
+          <a:prstGeom prst="rect">
+            <a:avLst/>
+          </a:prstGeom>
+          <a:solidFill>
+            <a:srgbClr val="8E6F3E"/>
+          </a:solidFill>
+          <a:ln>
+            <a:noFill/>
+          </a:ln>
+        </p:spPr>
+        <p:txBody>
           <a:bodyPr wrap="square" lIns="91440" tIns="45720" rIns="91440" bIns="45720" anchor="ctr"/>
           <a:lstStyle/>
           <a:p>
@@ -15699,12 +16280,438 @@
               <a:buNone/>
             </a:pPr>
             <a:r>
-              <a:rPr lang="en-US" sz="2000" b="1" i="0" dirty="0">
+              <a:rPr lang="en-US" sz="1900" b="1" i="0" dirty="0">
                 <a:solidFill>
                   <a:srgbClr val="FFFFFF"/>
                 </a:solidFill>
               </a:rPr>
-              <a:t>Temporal compression can turn incidents into evidence of structure.</a:t>
+              <a:t>DECIDE</a:t>
+            </a:r>
+          </a:p>
+        </p:txBody>
+      </p:sp>
+      <p:sp>
+        <p:nvSpPr>
+          <p:cNvPr id="121" name="C"/>
+          <p:cNvSpPr/>
+          <p:nvPr/>
+        </p:nvSpPr>
+        <p:spPr>
+          <a:xfrm>
+            <a:off x="2546000" y="4050000"/>
+            <a:ext cx="28000" cy="130000"/>
+          </a:xfrm>
+          <a:prstGeom prst="rect">
+            <a:avLst/>
+          </a:prstGeom>
+          <a:solidFill>
+            <a:srgbClr val="5C4826"/>
+          </a:solidFill>
+          <a:ln>
+            <a:noFill/>
+          </a:ln>
+        </p:spPr>
+        <p:txBody>
+          <a:bodyPr/>
+          <a:lstStyle/>
+          <a:p>
+            <a:endParaRPr/>
+          </a:p>
+        </p:txBody>
+      </p:sp>
+      <p:sp>
+        <p:nvSpPr>
+          <p:cNvPr id="122" name="Arrow"/>
+          <p:cNvSpPr/>
+          <p:nvPr/>
+        </p:nvSpPr>
+        <p:spPr>
+          <a:xfrm flipV="1">
+            <a:off x="2484000" y="4180000"/>
+            <a:ext cx="152000" cy="120000"/>
+          </a:xfrm>
+          <a:prstGeom prst="triangle">
+            <a:avLst/>
+          </a:prstGeom>
+          <a:solidFill>
+            <a:srgbClr val="5C4826"/>
+          </a:solidFill>
+          <a:ln>
+            <a:noFill/>
+          </a:ln>
+        </p:spPr>
+        <p:txBody>
+          <a:bodyPr/>
+          <a:lstStyle/>
+          <a:p>
+            <a:endParaRPr/>
+          </a:p>
+        </p:txBody>
+      </p:sp>
+      <p:sp>
+        <p:nvSpPr>
+          <p:cNvPr id="123" name="ExtractModel"/>
+          <p:cNvSpPr/>
+          <p:nvPr/>
+        </p:nvSpPr>
+        <p:spPr>
+          <a:xfrm>
+            <a:off x="1410000" y="4310000"/>
+            <a:ext cx="2300000" cy="480000"/>
+          </a:xfrm>
+          <a:prstGeom prst="rect">
+            <a:avLst/>
+          </a:prstGeom>
+          <a:solidFill>
+            <a:srgbClr val="5C4826"/>
+          </a:solidFill>
+          <a:ln>
+            <a:noFill/>
+          </a:ln>
+        </p:spPr>
+        <p:txBody>
+          <a:bodyPr wrap="square" lIns="91440" tIns="45720" rIns="91440" bIns="45720" anchor="ctr"/>
+          <a:lstStyle/>
+          <a:p>
+            <a:pPr algn="ctr">
+              <a:buNone/>
+            </a:pPr>
+            <a:r>
+              <a:rPr lang="en-US" sz="1700" b="1" i="0" dirty="0">
+                <a:solidFill>
+                  <a:srgbClr val="FFFFFF"/>
+                </a:solidFill>
+              </a:rPr>
+              <a:t>EXTRACT THE MODEL</a:t>
+            </a:r>
+          </a:p>
+        </p:txBody>
+      </p:sp>
+      <p:sp>
+        <p:nvSpPr>
+          <p:cNvPr id="124" name="ExtractOutputs"/>
+          <p:cNvSpPr txBox="1"/>
+          <p:nvPr/>
+        </p:nvSpPr>
+        <p:spPr>
+          <a:xfrm>
+            <a:off x="1060000" y="4820000"/>
+            <a:ext cx="3000000" cy="280000"/>
+          </a:xfrm>
+          <a:prstGeom prst="rect">
+            <a:avLst/>
+          </a:prstGeom>
+          <a:noFill/>
+          <a:ln>
+            <a:noFill/>
+          </a:ln>
+        </p:spPr>
+        <p:txBody>
+          <a:bodyPr wrap="square" lIns="0" tIns="0" rIns="0" bIns="0" anchor="t"/>
+          <a:lstStyle/>
+          <a:p>
+            <a:pPr algn="ctr">
+              <a:buNone/>
+            </a:pPr>
+            <a:r>
+              <a:rPr lang="en-US" sz="1300" b="1" i="0" dirty="0">
+                <a:solidFill>
+                  <a:srgbClr val="5C4826"/>
+                </a:solidFill>
+              </a:rPr>
+              <a:t>design · constraint · rule</a:t>
+            </a:r>
+          </a:p>
+        </p:txBody>
+      </p:sp>
+      <p:sp>
+        <p:nvSpPr>
+          <p:cNvPr id="125" name="RecordNote"/>
+          <p:cNvSpPr txBox="1"/>
+          <p:nvPr/>
+        </p:nvSpPr>
+        <p:spPr>
+          <a:xfrm>
+            <a:off x="760000" y="5120000"/>
+            <a:ext cx="3600000" cy="540000"/>
+          </a:xfrm>
+          <a:prstGeom prst="rect">
+            <a:avLst/>
+          </a:prstGeom>
+          <a:noFill/>
+          <a:ln>
+            <a:noFill/>
+          </a:ln>
+        </p:spPr>
+        <p:txBody>
+          <a:bodyPr wrap="square" lIns="0" tIns="0" rIns="0" bIns="0" anchor="t"/>
+          <a:lstStyle/>
+          <a:p>
+            <a:pPr algn="ctr">
+              <a:buNone/>
+            </a:pPr>
+            <a:r>
+              <a:rPr lang="en-US" sz="1150" b="0" i="1" dirty="0">
+                <a:solidFill>
+                  <a:srgbClr val="555960"/>
+                </a:solidFill>
+              </a:rPr>
+              <a:t>Record the mechanism, the property it preserves, and the evidence that justified it.</a:t>
+            </a:r>
+          </a:p>
+        </p:txBody>
+      </p:sp>
+      <p:sp>
+        <p:nvSpPr>
+          <p:cNvPr id="130" name="ExamplePanel"/>
+          <p:cNvSpPr/>
+          <p:nvPr/>
+        </p:nvSpPr>
+        <p:spPr>
+          <a:xfrm>
+            <a:off x="5150000" y="800000"/>
+            <a:ext cx="3700000" cy="2960000"/>
+          </a:xfrm>
+          <a:prstGeom prst="rect">
+            <a:avLst/>
+          </a:prstGeom>
+          <a:solidFill>
+            <a:srgbClr val="F5F1E8"/>
+          </a:solidFill>
+          <a:ln w="12700">
+            <a:solidFill>
+              <a:srgbClr val="C9B991"/>
+            </a:solidFill>
+          </a:ln>
+        </p:spPr>
+        <p:txBody>
+          <a:bodyPr wrap="square" lIns="137160" tIns="91440" rIns="137160" bIns="91440" anchor="t"/>
+          <a:lstStyle/>
+          <a:p>
+            <a:pPr algn="l">
+              <a:buNone/>
+            </a:pPr>
+            <a:r>
+              <a:rPr lang="en-US" sz="1500" b="1" i="0" dirty="0">
+                <a:solidFill>
+                  <a:srgbClr val="5C4826"/>
+                </a:solidFill>
+              </a:rPr>
+              <a:t>THE DOCUMENT DECISION</a:t>
+            </a:r>
+          </a:p>
+          <a:p>
+            <a:pPr algn="l">
+              <a:spcBef>
+                <a:spcPts val="600"/>
+              </a:spcBef>
+              <a:buNone/>
+            </a:pPr>
+            <a:r>
+              <a:rPr lang="en-US" sz="1250" b="1" i="0" dirty="0">
+                <a:solidFill>
+                  <a:srgbClr val="000000"/>
+                </a:solidFill>
+              </a:rPr>
+              <a:t>Decision:</a:t>
+            </a:r>
+            <a:r>
+              <a:rPr lang="en-US" sz="1250" b="0" i="0" dirty="0">
+                <a:solidFill>
+                  <a:srgbClr val="000000"/>
+                </a:solidFill>
+              </a:rPr>
+              <a:t xml:space="preserve"> load, stream, or intermediate representation?</a:t>
+            </a:r>
+          </a:p>
+          <a:p>
+            <a:pPr algn="l">
+              <a:spcBef>
+                <a:spcPts val="500"/>
+              </a:spcBef>
+              <a:buNone/>
+            </a:pPr>
+            <a:r>
+              <a:rPr lang="en-US" sz="1250" b="1" i="0" dirty="0">
+                <a:solidFill>
+                  <a:srgbClr val="000000"/>
+                </a:solidFill>
+              </a:rPr>
+              <a:t>Uncertainty:</a:t>
+            </a:r>
+            <a:r>
+              <a:rPr lang="en-US" sz="1250" b="0" i="0" dirty="0">
+                <a:solidFill>
+                  <a:srgbClr val="000000"/>
+                </a:solidFill>
+              </a:rPr>
+              <a:t xml:space="preserve"> actual peak memory and latency under the workload</a:t>
+            </a:r>
+          </a:p>
+          <a:p>
+            <a:pPr algn="l">
+              <a:spcBef>
+                <a:spcPts val="500"/>
+              </a:spcBef>
+              <a:buNone/>
+            </a:pPr>
+            <a:r>
+              <a:rPr lang="en-US" sz="1250" b="1" i="0" dirty="0">
+                <a:solidFill>
+                  <a:srgbClr val="000000"/>
+                </a:solidFill>
+              </a:rPr>
+              <a:t>Probe:</a:t>
+            </a:r>
+            <a:r>
+              <a:rPr lang="en-US" sz="1250" b="0" i="0" dirty="0">
+                <a:solidFill>
+                  <a:srgbClr val="000000"/>
+                </a:solidFill>
+              </a:rPr>
+              <a:t xml:space="preserve"> implement enough of the alternatives to expose the difference</a:t>
+            </a:r>
+          </a:p>
+          <a:p>
+            <a:pPr algn="l">
+              <a:spcBef>
+                <a:spcPts val="500"/>
+              </a:spcBef>
+              <a:buNone/>
+            </a:pPr>
+            <a:r>
+              <a:rPr lang="en-US" sz="1250" b="1" i="0" dirty="0">
+                <a:solidFill>
+                  <a:srgbClr val="000000"/>
+                </a:solidFill>
+              </a:rPr>
+              <a:t>Measure:</a:t>
+            </a:r>
+            <a:r>
+              <a:rPr lang="en-US" sz="1250" b="0" i="0" dirty="0">
+                <a:solidFill>
+                  <a:srgbClr val="000000"/>
+                </a:solidFill>
+              </a:rPr>
+              <a:t xml:space="preserve"> peak memory · latency</a:t>
+            </a:r>
+          </a:p>
+          <a:p>
+            <a:pPr algn="l">
+              <a:spcBef>
+                <a:spcPts val="500"/>
+              </a:spcBef>
+              <a:buNone/>
+            </a:pPr>
+            <a:r>
+              <a:rPr lang="en-US" sz="1250" b="1" i="0" dirty="0">
+                <a:solidFill>
+                  <a:srgbClr val="000000"/>
+                </a:solidFill>
+              </a:rPr>
+              <a:t>Learn:</a:t>
+            </a:r>
+            <a:r>
+              <a:rPr lang="en-US" sz="1250" b="0" i="0" dirty="0">
+                <a:solidFill>
+                  <a:srgbClr val="000000"/>
+                </a:solidFill>
+              </a:rPr>
+              <a:t xml:space="preserve"> which mechanism satisfies the inherited constraints</a:t>
+            </a:r>
+          </a:p>
+        </p:txBody>
+      </p:sp>
+      <p:sp>
+        <p:nvSpPr>
+          <p:cNvPr id="131" name="TurnQuote"/>
+          <p:cNvSpPr/>
+          <p:nvPr/>
+        </p:nvSpPr>
+        <p:spPr>
+          <a:xfrm>
+            <a:off x="5150000" y="3860000"/>
+            <a:ext cx="3700000" cy="1800000"/>
+          </a:xfrm>
+          <a:prstGeom prst="rect">
+            <a:avLst/>
+          </a:prstGeom>
+          <a:solidFill>
+            <a:srgbClr val="8E6F3E"/>
+          </a:solidFill>
+          <a:ln>
+            <a:noFill/>
+          </a:ln>
+        </p:spPr>
+        <p:txBody>
+          <a:bodyPr wrap="square" lIns="137160" tIns="91440" rIns="137160" bIns="91440" anchor="ctr"/>
+          <a:lstStyle/>
+          <a:p>
+            <a:pPr algn="l">
+              <a:buNone/>
+            </a:pPr>
+            <a:r>
+              <a:rPr lang="en-US" sz="1650" b="0" i="0" dirty="0">
+                <a:solidFill>
+                  <a:srgbClr val="FFFFFF"/>
+                </a:solidFill>
+              </a:rPr>
+              <a:t>The implementation answered the question.</a:t>
+            </a:r>
+          </a:p>
+          <a:p>
+            <a:pPr algn="l">
+              <a:spcBef>
+                <a:spcPts val="900"/>
+              </a:spcBef>
+              <a:buNone/>
+            </a:pPr>
+            <a:r>
+              <a:rPr lang="en-US" sz="1900" b="1" i="0" dirty="0">
+                <a:solidFill>
+                  <a:srgbClr val="FFFFFF"/>
+                </a:solidFill>
+              </a:rPr>
+              <a:t>Preserve the answer outside the implementation.</a:t>
+            </a:r>
+          </a:p>
+        </p:txBody>
+      </p:sp>
+      <p:sp>
+        <p:nvSpPr>
+          <p:cNvPr id="140" name="FooterBand"/>
+          <p:cNvSpPr/>
+          <p:nvPr/>
+        </p:nvSpPr>
+        <p:spPr>
+          <a:xfrm>
+            <a:off x="274320" y="5852160"/>
+            <a:ext cx="8595360" cy="566928"/>
+          </a:xfrm>
+          <a:prstGeom prst="rect">
+            <a:avLst/>
+          </a:prstGeom>
+          <a:solidFill>
+            <a:srgbClr val="8E6F3E"/>
+          </a:solidFill>
+          <a:ln>
+            <a:noFill/>
+          </a:ln>
+        </p:spPr>
+        <p:txBody>
+          <a:bodyPr wrap="square" lIns="91440" tIns="45720" rIns="91440" bIns="45720" anchor="ctr"/>
+          <a:lstStyle/>
+          <a:p>
+            <a:pPr algn="ctr">
+              <a:buNone/>
+            </a:pPr>
+            <a:r>
+              <a:rPr lang="en-US" sz="1900" b="1" i="0" dirty="0">
+                <a:solidFill>
+                  <a:srgbClr val="FFFFFF"/>
+                </a:solidFill>
+              </a:rPr>
+              <a:t>Cheap implementation changes the economics of acquiring Design evidence.</a:t>
             </a:r>
           </a:p>
         </p:txBody>
@@ -15714,182 +16721,6 @@
   <p:clrMapOvr>
     <a:masterClrMapping/>
   </p:clrMapOvr>
-  <p:timing>
-    <p:tnLst>
-      <p:par>
-        <p:cTn id="1" dur="indefinite" restart="never" nodeType="tmRoot">
-          <p:childTnLst>
-            <p:seq concurrent="1" nextAc="seek">
-              <p:cTn id="2" dur="indefinite" nodeType="mainSeq">
-                <p:childTnLst>
-                  <p:par>
-                    <p:cTn id="3" fill="hold">
-                      <p:stCondLst>
-                        <p:cond delay="indefinite"/>
-                      </p:stCondLst>
-                      <p:childTnLst>
-                        <p:par>
-                          <p:cTn id="4" fill="hold">
-                            <p:stCondLst>
-                              <p:cond delay="0"/>
-                            </p:stCondLst>
-                            <p:childTnLst>
-                              <p:par>
-                                <p:cTn id="5" presetID="10" presetClass="entr" presetSubtype="0" fill="hold" grpId="0" nodeType="clickEffect">
-                                  <p:stCondLst>
-                                    <p:cond delay="0"/>
-                                  </p:stCondLst>
-                                  <p:childTnLst>
-                                    <p:set>
-                                      <p:cBhvr>
-                                        <p:cTn id="6" dur="1" fill="hold">
-                                          <p:stCondLst>
-                                            <p:cond delay="0"/>
-                                          </p:stCondLst>
-                                        </p:cTn>
-                                        <p:tgtEl>
-                                          <p:spTgt spid="102"/>
-                                        </p:tgtEl>
-                                        <p:attrNameLst>
-                                          <p:attrName>style.visibility</p:attrName>
-                                        </p:attrNameLst>
-                                      </p:cBhvr>
-                                      <p:to>
-                                        <p:strVal val="visible"/>
-                                      </p:to>
-                                    </p:set>
-                                    <p:animEffect transition="in" filter="fade">
-                                      <p:cBhvr>
-                                        <p:cTn id="7" dur="500"/>
-                                        <p:tgtEl>
-                                          <p:spTgt spid="102"/>
-                                        </p:tgtEl>
-                                      </p:cBhvr>
-                                    </p:animEffect>
-                                  </p:childTnLst>
-                                </p:cTn>
-                              </p:par>
-                            </p:childTnLst>
-                          </p:cTn>
-                        </p:par>
-                        <p:par>
-                          <p:cTn id="8" fill="hold">
-                            <p:stCondLst>
-                              <p:cond delay="0"/>
-                            </p:stCondLst>
-                            <p:childTnLst>
-                              <p:par>
-                                <p:cTn id="9" presetID="10" presetClass="entr" presetSubtype="0" fill="hold" grpId="1" nodeType="withEffect">
-                                  <p:stCondLst>
-                                    <p:cond delay="0"/>
-                                  </p:stCondLst>
-                                  <p:childTnLst>
-                                    <p:set>
-                                      <p:cBhvr>
-                                        <p:cTn id="10" dur="1" fill="hold">
-                                          <p:stCondLst>
-                                            <p:cond delay="0"/>
-                                          </p:stCondLst>
-                                        </p:cTn>
-                                        <p:tgtEl>
-                                          <p:spTgt spid="103"/>
-                                        </p:tgtEl>
-                                        <p:attrNameLst>
-                                          <p:attrName>style.visibility</p:attrName>
-                                        </p:attrNameLst>
-                                      </p:cBhvr>
-                                      <p:to>
-                                        <p:strVal val="visible"/>
-                                      </p:to>
-                                    </p:set>
-                                    <p:animEffect transition="in" filter="fade">
-                                      <p:cBhvr>
-                                        <p:cTn id="11" dur="500"/>
-                                        <p:tgtEl>
-                                          <p:spTgt spid="103"/>
-                                        </p:tgtEl>
-                                      </p:cBhvr>
-                                    </p:animEffect>
-                                  </p:childTnLst>
-                                </p:cTn>
-                              </p:par>
-                            </p:childTnLst>
-                          </p:cTn>
-                        </p:par>
-                        <p:par>
-                          <p:cTn id="12" fill="hold">
-                            <p:stCondLst>
-                              <p:cond delay="0"/>
-                            </p:stCondLst>
-                            <p:childTnLst>
-                              <p:par>
-                                <p:cTn id="13" presetID="10" presetClass="entr" presetSubtype="0" fill="hold" grpId="2" nodeType="withEffect">
-                                  <p:stCondLst>
-                                    <p:cond delay="0"/>
-                                  </p:stCondLst>
-                                  <p:childTnLst>
-                                    <p:set>
-                                      <p:cBhvr>
-                                        <p:cTn id="14" dur="1" fill="hold">
-                                          <p:stCondLst>
-                                            <p:cond delay="0"/>
-                                          </p:stCondLst>
-                                        </p:cTn>
-                                        <p:tgtEl>
-                                          <p:spTgt spid="104"/>
-                                        </p:tgtEl>
-                                        <p:attrNameLst>
-                                          <p:attrName>style.visibility</p:attrName>
-                                        </p:attrNameLst>
-                                      </p:cBhvr>
-                                      <p:to>
-                                        <p:strVal val="visible"/>
-                                      </p:to>
-                                    </p:set>
-                                    <p:animEffect transition="in" filter="fade">
-                                      <p:cBhvr>
-                                        <p:cTn id="15" dur="500"/>
-                                        <p:tgtEl>
-                                          <p:spTgt spid="104"/>
-                                        </p:tgtEl>
-                                      </p:cBhvr>
-                                    </p:animEffect>
-                                  </p:childTnLst>
-                                </p:cTn>
-                              </p:par>
-                            </p:childTnLst>
-                          </p:cTn>
-                        </p:par>
-                      </p:childTnLst>
-                    </p:cTn>
-                  </p:par>
-                </p:childTnLst>
-              </p:cTn>
-              <p:prevCondLst>
-                <p:cond evt="onPrev" delay="0">
-                  <p:tgtEl>
-                    <p:sldTgt/>
-                  </p:tgtEl>
-                </p:cond>
-              </p:prevCondLst>
-              <p:nextCondLst>
-                <p:cond evt="onNext" delay="0">
-                  <p:tgtEl>
-                    <p:sldTgt/>
-                  </p:tgtEl>
-                </p:cond>
-              </p:nextCondLst>
-            </p:seq>
-          </p:childTnLst>
-        </p:cTn>
-      </p:par>
-    </p:tnLst>
-    <p:bldLst>
-      <p:bldP spid="102" grpId="0"/>
-      <p:bldP spid="103" grpId="1"/>
-      <p:bldP spid="104" grpId="2"/>
-    </p:bldLst>
-  </p:timing>
 </p:sld>
 </file>
 
@@ -21492,7 +22323,7 @@
                   <a:srgbClr val="555960"/>
                 </a:solidFill>
               </a:rPr>
-              <a:t>→ evidence decides</a:t>
+              <a:t>→ evidence informs the decision</a:t>
             </a:r>
           </a:p>
         </p:txBody>
@@ -21766,7 +22597,7 @@
                   <a:srgbClr val="9A9A9A"/>
                 </a:solidFill>
               </a:rPr>
-              <a:t>  ·  </a:t>
+              <a:t xml:space="preserve">  ·  </a:t>
             </a:r>
             <a:r>
               <a:rPr lang="en-US" sz="2200" b="1" i="0" dirty="0">
@@ -21782,7 +22613,7 @@
                   <a:srgbClr val="9A9A9A"/>
                 </a:solidFill>
               </a:rPr>
-              <a:t>  ·  </a:t>
+              <a:t xml:space="preserve">  ·  </a:t>
             </a:r>
             <a:r>
               <a:rPr lang="en-US" sz="2200" b="1" i="0" dirty="0">
@@ -23508,7 +24339,7 @@
                   <a:srgbClr val="FFFFFF"/>
                 </a:solidFill>
               </a:rPr>
-              <a:t>The inherited constraint decides which consequence matters. Here: peak memory.</a:t>
+              <a:t>The inherited constraint makes peak memory consequential here.</a:t>
             </a:r>
           </a:p>
         </p:txBody>
@@ -26318,7 +27149,7 @@
                   <a:srgbClr val="000000"/>
                 </a:solidFill>
               </a:rPr>
-              <a:t>A Design can satisfy its own local responsibility while quietly destroying a property that Architecture was intended to establish.</a:t>
+              <a:t>A design can satisfy its own local responsibility while quietly destroying a property that Architecture was intended to establish.</a:t>
             </a:r>
           </a:p>
         </p:txBody>
@@ -28913,7 +29744,7 @@
                   <a:srgbClr val="9A9A9A"/>
                 </a:solidFill>
               </a:rPr>
-              <a:t>  ·  </a:t>
+              <a:t xml:space="preserve">  ·  </a:t>
             </a:r>
             <a:r>
               <a:rPr lang="en-US" sz="2000" b="1" i="0" dirty="0">
@@ -28929,7 +29760,7 @@
                   <a:srgbClr val="9A9A9A"/>
                 </a:solidFill>
               </a:rPr>
-              <a:t>  ·  </a:t>
+              <a:t xml:space="preserve">  ·  </a:t>
             </a:r>
             <a:r>
               <a:rPr lang="en-US" sz="2000" b="1" i="0" dirty="0">

</xml_diff>